<commit_message>
Show examples before ten-prompt overview and simplify headings
</commit_message>
<xml_diff>
--- a/downloads/Gemini-Notebook-Workshop.pptx
+++ b/downloads/Gemini-Notebook-Workshop.pptx
@@ -6243,30 +6243,33 @@
       </p:pic>
       <p:sp>
         <p:nvSpPr>
-          <p:cNvPr id="3" name="prompt_menu-text-2"/>
-          <p:cNvSpPr/>
-          <p:nvPr/>
-        </p:nvSpPr>
-        <p:spPr>
-          <a:xfrm>
-            <a:off x="762000" y="952500"/>
-            <a:ext cx="14732000" cy="1003300"/>
-          </a:xfrm>
-          <a:prstGeom prst="rect">
-            <a:avLst/>
-          </a:prstGeom>
-          <a:noFill/>
-          <a:ln/>
-        </p:spPr>
-        <p:txBody>
-          <a:bodyPr wrap="square" lIns="0" tIns="0" rIns="0" bIns="0" rtlCol="0" anchor="t"/>
-          <a:lstStyle/>
-          <a:p>
-            <a:pPr algn="l" indent="0" marL="0">
-              <a:buNone/>
-            </a:pPr>
-            <a:r>
-              <a:rPr lang="en-US" altLang="en-US" sz="5400" b="1" dirty="0">
+          <p:cNvPr id="3" name="example_context-text-2"/>
+          <p:cNvSpPr/>
+          <p:nvPr/>
+        </p:nvSpPr>
+        <p:spPr>
+          <a:xfrm>
+            <a:off x="762000" y="889000"/>
+            <a:ext cx="14732000" cy="1651000"/>
+          </a:xfrm>
+          <a:prstGeom prst="rect">
+            <a:avLst/>
+          </a:prstGeom>
+          <a:noFill/>
+          <a:ln/>
+        </p:spPr>
+        <p:txBody>
+          <a:bodyPr wrap="square" lIns="0" tIns="0" rIns="0" bIns="0" rtlCol="0" anchor="t"/>
+          <a:lstStyle/>
+          <a:p>
+            <a:pPr algn="l" indent="0" marL="0">
+              <a:lnSpc>
+                <a:spcPts val="5512"/>
+              </a:lnSpc>
+              <a:buNone/>
+            </a:pPr>
+            <a:r>
+              <a:rPr lang="en-US" altLang="en-US" sz="5200" b="1" dirty="0">
                 <a:solidFill>
                   <a:srgbClr val="111111"/>
                 </a:solidFill>
@@ -6274,21 +6277,41 @@
                 <a:ea typeface="Arial" pitchFamily="34" charset="-122"/>
                 <a:cs typeface="Arial" pitchFamily="34" charset="-120"/>
               </a:rPr>
-              <a:t>Ten useful prompts for teachers.</a:t>
-            </a:r>
-            <a:endParaRPr lang="en-US" sz="5400" dirty="0"/>
-          </a:p>
-        </p:txBody>
-      </p:sp>
-      <p:sp>
-        <p:nvSpPr>
-          <p:cNvPr id="4" name="prompt_menu-shape-3"/>
-          <p:cNvSpPr/>
-          <p:nvPr/>
-        </p:nvSpPr>
-        <p:spPr>
-          <a:xfrm>
-            <a:off x="762000" y="2247900"/>
+              <a:t>Example</a:t>
+            </a:r>
+            <a:endParaRPr lang="en-US" sz="5200" dirty="0"/>
+          </a:p>
+          <a:p>
+            <a:pPr algn="l" indent="0" marL="0">
+              <a:lnSpc>
+                <a:spcPts val="5512"/>
+              </a:lnSpc>
+              <a:buNone/>
+            </a:pPr>
+            <a:r>
+              <a:rPr lang="en-US" altLang="en-US" sz="5200" b="1" dirty="0">
+                <a:solidFill>
+                  <a:srgbClr val="E74627"/>
+                </a:solidFill>
+                <a:latin typeface="Arial" pitchFamily="34" charset="0"/>
+                <a:ea typeface="Arial" pitchFamily="34" charset="-122"/>
+                <a:cs typeface="Arial" pitchFamily="34" charset="-120"/>
+              </a:rPr>
+              <a:t>Check S6 English reading materials.</a:t>
+            </a:r>
+            <a:endParaRPr lang="en-US" sz="5200" dirty="0"/>
+          </a:p>
+        </p:txBody>
+      </p:sp>
+      <p:sp>
+        <p:nvSpPr>
+          <p:cNvPr id="4" name="example_context-shape-3"/>
+          <p:cNvSpPr/>
+          <p:nvPr/>
+        </p:nvSpPr>
+        <p:spPr>
+          <a:xfrm>
+            <a:off x="762000" y="2781300"/>
             <a:ext cx="14732000" cy="9144"/>
           </a:xfrm>
           <a:prstGeom prst="line">
@@ -6304,14 +6327,95 @@
       </p:sp>
       <p:sp>
         <p:nvSpPr>
-          <p:cNvPr id="5" name="prompt_menu-shape-4"/>
-          <p:cNvSpPr/>
-          <p:nvPr/>
-        </p:nvSpPr>
-        <p:spPr>
-          <a:xfrm>
-            <a:off x="8140700" y="2717800"/>
-            <a:ext cx="9144" cy="4813300"/>
+          <p:cNvPr id="5" name="example_context-text-4"/>
+          <p:cNvSpPr/>
+          <p:nvPr/>
+        </p:nvSpPr>
+        <p:spPr>
+          <a:xfrm>
+            <a:off x="762000" y="3098800"/>
+            <a:ext cx="14732000" cy="495300"/>
+          </a:xfrm>
+          <a:prstGeom prst="rect">
+            <a:avLst/>
+          </a:prstGeom>
+          <a:noFill/>
+          <a:ln/>
+        </p:spPr>
+        <p:txBody>
+          <a:bodyPr wrap="square" lIns="0" tIns="0" rIns="0" bIns="0" rtlCol="0" anchor="t"/>
+          <a:lstStyle/>
+          <a:p>
+            <a:pPr algn="l" indent="0" marL="0">
+              <a:buNone/>
+            </a:pPr>
+            <a:r>
+              <a:rPr lang="en-US" altLang="en-US" sz="2800" b="1" dirty="0">
+                <a:solidFill>
+                  <a:srgbClr val="E74627"/>
+                </a:solidFill>
+                <a:latin typeface="Arial" pitchFamily="34" charset="0"/>
+                <a:ea typeface="Arial" pitchFamily="34" charset="-122"/>
+                <a:cs typeface="Arial" pitchFamily="34" charset="-120"/>
+              </a:rPr>
+              <a:t>Situation</a:t>
+            </a:r>
+            <a:endParaRPr lang="en-US" sz="2800" dirty="0"/>
+          </a:p>
+        </p:txBody>
+      </p:sp>
+      <p:sp>
+        <p:nvSpPr>
+          <p:cNvPr id="6" name="example_context-text-5"/>
+          <p:cNvSpPr/>
+          <p:nvPr/>
+        </p:nvSpPr>
+        <p:spPr>
+          <a:xfrm>
+            <a:off x="762000" y="3683000"/>
+            <a:ext cx="14732000" cy="1333500"/>
+          </a:xfrm>
+          <a:prstGeom prst="rect">
+            <a:avLst/>
+          </a:prstGeom>
+          <a:noFill/>
+          <a:ln/>
+        </p:spPr>
+        <p:txBody>
+          <a:bodyPr wrap="square" lIns="0" tIns="0" rIns="0" bIns="0" rtlCol="0" anchor="t"/>
+          <a:lstStyle/>
+          <a:p>
+            <a:pPr algn="l" indent="0" marL="0">
+              <a:lnSpc>
+                <a:spcPts val="3540"/>
+              </a:lnSpc>
+              <a:buNone/>
+            </a:pPr>
+            <a:r>
+              <a:rPr lang="en-US" altLang="en-US" sz="3000" dirty="0">
+                <a:solidFill>
+                  <a:srgbClr val="111111"/>
+                </a:solidFill>
+                <a:latin typeface="Arial" pitchFamily="34" charset="0"/>
+                <a:ea typeface="Arial" pitchFamily="34" charset="-122"/>
+                <a:cs typeface="Arial" pitchFamily="34" charset="-120"/>
+              </a:rPr>
+              <a:t>Before planning S6 revision, an English teacher wants to know whether the school’s reading-comprehension notes address the skills identified in the selected official guidance.</a:t>
+            </a:r>
+            <a:endParaRPr lang="en-US" sz="3000" dirty="0"/>
+          </a:p>
+        </p:txBody>
+      </p:sp>
+      <p:sp>
+        <p:nvSpPr>
+          <p:cNvPr id="7" name="example_context-shape-6"/>
+          <p:cNvSpPr/>
+          <p:nvPr/>
+        </p:nvSpPr>
+        <p:spPr>
+          <a:xfrm>
+            <a:off x="762000" y="5295900"/>
+            <a:ext cx="14732000" cy="9144"/>
           </a:xfrm>
           <a:prstGeom prst="line">
             <a:avLst/>
@@ -6326,30 +6430,30 @@
       </p:sp>
       <p:sp>
         <p:nvSpPr>
-          <p:cNvPr id="6" name="prompt_menu-text-5"/>
-          <p:cNvSpPr/>
-          <p:nvPr/>
-        </p:nvSpPr>
-        <p:spPr>
-          <a:xfrm>
-            <a:off x="762000" y="2743200"/>
-            <a:ext cx="762000" cy="558800"/>
-          </a:xfrm>
-          <a:prstGeom prst="rect">
-            <a:avLst/>
-          </a:prstGeom>
-          <a:noFill/>
-          <a:ln/>
-        </p:spPr>
-        <p:txBody>
-          <a:bodyPr wrap="square" lIns="0" tIns="0" rIns="0" bIns="0" rtlCol="0" anchor="t"/>
-          <a:lstStyle/>
-          <a:p>
-            <a:pPr algn="l" indent="0" marL="0">
-              <a:buNone/>
-            </a:pPr>
-            <a:r>
-              <a:rPr lang="en-US" altLang="en-US" sz="3100" b="1" dirty="0">
+          <p:cNvPr id="8" name="example_context-text-7"/>
+          <p:cNvSpPr/>
+          <p:nvPr/>
+        </p:nvSpPr>
+        <p:spPr>
+          <a:xfrm>
+            <a:off x="762000" y="5588000"/>
+            <a:ext cx="14732000" cy="508000"/>
+          </a:xfrm>
+          <a:prstGeom prst="rect">
+            <a:avLst/>
+          </a:prstGeom>
+          <a:noFill/>
+          <a:ln/>
+        </p:spPr>
+        <p:txBody>
+          <a:bodyPr wrap="square" lIns="0" tIns="0" rIns="0" bIns="0" rtlCol="0" anchor="t"/>
+          <a:lstStyle/>
+          <a:p>
+            <a:pPr algn="l" indent="0" marL="0">
+              <a:buNone/>
+            </a:pPr>
+            <a:r>
+              <a:rPr lang="en-US" altLang="en-US" sz="2800" b="1" dirty="0">
                 <a:solidFill>
                   <a:srgbClr val="E74627"/>
                 </a:solidFill>
@@ -6357,41 +6461,48 @@
                 <a:ea typeface="Arial" pitchFamily="34" charset="-122"/>
                 <a:cs typeface="Arial" pitchFamily="34" charset="-120"/>
               </a:rPr>
-              <a:t>01</a:t>
-            </a:r>
-            <a:endParaRPr lang="en-US" sz="3100" dirty="0"/>
-          </a:p>
-        </p:txBody>
-      </p:sp>
-      <p:sp>
-        <p:nvSpPr>
-          <p:cNvPr id="7" name="prompt_menu-text-6"/>
-          <p:cNvSpPr/>
-          <p:nvPr/>
-        </p:nvSpPr>
-        <p:spPr>
-          <a:xfrm>
-            <a:off x="1536700" y="2717800"/>
-            <a:ext cx="6248400" cy="812800"/>
-          </a:xfrm>
-          <a:prstGeom prst="rect">
-            <a:avLst/>
-          </a:prstGeom>
-          <a:noFill/>
-          <a:ln/>
-        </p:spPr>
-        <p:txBody>
-          <a:bodyPr wrap="square" lIns="0" tIns="0" rIns="0" bIns="0" rtlCol="0" anchor="t"/>
-          <a:lstStyle/>
-          <a:p>
-            <a:pPr algn="l" indent="0" marL="0">
+              <a:t>Sources to add to Notebook</a:t>
+            </a:r>
+            <a:endParaRPr lang="en-US" sz="2800" dirty="0"/>
+          </a:p>
+        </p:txBody>
+      </p:sp>
+      <p:sp>
+        <p:nvSpPr>
+          <p:cNvPr id="9" name="example_context-text-8"/>
+          <p:cNvSpPr/>
+          <p:nvPr/>
+        </p:nvSpPr>
+        <p:spPr>
+          <a:xfrm>
+            <a:off x="762000" y="6223000"/>
+            <a:ext cx="14732000" cy="1562100"/>
+          </a:xfrm>
+          <a:prstGeom prst="rect">
+            <a:avLst/>
+          </a:prstGeom>
+          <a:noFill/>
+          <a:ln/>
+        </p:spPr>
+        <p:txBody>
+          <a:bodyPr wrap="square" lIns="0" tIns="0" rIns="0" bIns="0" rtlCol="0" anchor="t"/>
+          <a:lstStyle/>
+          <a:p>
+            <a:pPr algn="l" marL="444500" indent="-444500">
               <a:lnSpc>
-                <a:spcPts val="2990"/>
+                <a:spcPts val="3500"/>
               </a:lnSpc>
-              <a:buNone/>
-            </a:pPr>
-            <a:r>
-              <a:rPr lang="en-US" altLang="en-US" sz="2600" dirty="0">
+              <a:spcBef>
+                <a:spcPts val="10"/>
+              </a:spcBef>
+              <a:spcAft>
+                <a:spcPts val="500"/>
+              </a:spcAft>
+              <a:buSzPct val="100000"/>
+              <a:buChar char="•"/>
+            </a:pPr>
+            <a:r>
+              <a:rPr lang="en-US" altLang="en-US" sz="2800" dirty="0">
                 <a:solidFill>
                   <a:srgbClr val="111111"/>
                 </a:solidFill>
@@ -6399,22 +6510,73 @@
                 <a:ea typeface="Arial" pitchFamily="34" charset="-122"/>
                 <a:cs typeface="Arial" pitchFamily="34" charset="-120"/>
               </a:rPr>
-              <a:t>Check materials against HKDSE requirements</a:t>
-            </a:r>
-            <a:endParaRPr lang="en-US" sz="2600" dirty="0"/>
-          </a:p>
-        </p:txBody>
-      </p:sp>
-      <p:sp>
-        <p:nvSpPr>
-          <p:cNvPr id="8" name="prompt_menu-shape-7"/>
-          <p:cNvSpPr/>
-          <p:nvPr/>
-        </p:nvSpPr>
-        <p:spPr>
-          <a:xfrm>
-            <a:off x="762000" y="3606800"/>
-            <a:ext cx="6985000" cy="9144"/>
+              <a:t>English Language Curriculum and Assessment Guide (Secondary 4 - 6)</a:t>
+            </a:r>
+            <a:endParaRPr lang="en-US" sz="2800" dirty="0"/>
+          </a:p>
+          <a:p>
+            <a:pPr algn="l" marL="444500" indent="-444500">
+              <a:lnSpc>
+                <a:spcPts val="3500"/>
+              </a:lnSpc>
+              <a:spcBef>
+                <a:spcPts val="10"/>
+              </a:spcBef>
+              <a:spcAft>
+                <a:spcPts val="500"/>
+              </a:spcAft>
+              <a:buSzPct val="100000"/>
+              <a:buChar char="•"/>
+            </a:pPr>
+            <a:r>
+              <a:rPr lang="en-US" altLang="en-US" sz="2800" dirty="0">
+                <a:solidFill>
+                  <a:srgbClr val="111111"/>
+                </a:solidFill>
+                <a:latin typeface="Arial" pitchFamily="34" charset="0"/>
+                <a:ea typeface="Arial" pitchFamily="34" charset="-122"/>
+                <a:cs typeface="Arial" pitchFamily="34" charset="-120"/>
+              </a:rPr>
+              <a:t>English Language Assessment Framework for HKDSE</a:t>
+            </a:r>
+            <a:endParaRPr lang="en-US" sz="2800" dirty="0"/>
+          </a:p>
+          <a:p>
+            <a:pPr algn="l" marL="444500" indent="-444500">
+              <a:lnSpc>
+                <a:spcPts val="3500"/>
+              </a:lnSpc>
+              <a:spcBef>
+                <a:spcPts val="10"/>
+              </a:spcBef>
+              <a:buSzPct val="100000"/>
+              <a:buChar char="•"/>
+            </a:pPr>
+            <a:r>
+              <a:rPr lang="en-US" altLang="en-US" sz="2800" dirty="0">
+                <a:solidFill>
+                  <a:srgbClr val="111111"/>
+                </a:solidFill>
+                <a:latin typeface="Arial" pitchFamily="34" charset="0"/>
+                <a:ea typeface="Arial" pitchFamily="34" charset="-122"/>
+                <a:cs typeface="Arial" pitchFamily="34" charset="-120"/>
+              </a:rPr>
+              <a:t>The related reading notes</a:t>
+            </a:r>
+            <a:endParaRPr lang="en-US" sz="2800" dirty="0"/>
+          </a:p>
+        </p:txBody>
+      </p:sp>
+      <p:sp>
+        <p:nvSpPr>
+          <p:cNvPr id="10" name="example_context-shape-9"/>
+          <p:cNvSpPr/>
+          <p:nvPr/>
+        </p:nvSpPr>
+        <p:spPr>
+          <a:xfrm>
+            <a:off x="762000" y="8102600"/>
+            <a:ext cx="14732000" cy="9144"/>
           </a:xfrm>
           <a:prstGeom prst="line">
             <a:avLst/>
@@ -6429,912 +6591,7 @@
       </p:sp>
       <p:sp>
         <p:nvSpPr>
-          <p:cNvPr id="9" name="prompt_menu-text-8"/>
-          <p:cNvSpPr/>
-          <p:nvPr/>
-        </p:nvSpPr>
-        <p:spPr>
-          <a:xfrm>
-            <a:off x="762000" y="3759200"/>
-            <a:ext cx="762000" cy="558800"/>
-          </a:xfrm>
-          <a:prstGeom prst="rect">
-            <a:avLst/>
-          </a:prstGeom>
-          <a:noFill/>
-          <a:ln/>
-        </p:spPr>
-        <p:txBody>
-          <a:bodyPr wrap="square" lIns="0" tIns="0" rIns="0" bIns="0" rtlCol="0" anchor="t"/>
-          <a:lstStyle/>
-          <a:p>
-            <a:pPr algn="l" indent="0" marL="0">
-              <a:buNone/>
-            </a:pPr>
-            <a:r>
-              <a:rPr lang="en-US" altLang="en-US" sz="3100" b="1" dirty="0">
-                <a:solidFill>
-                  <a:srgbClr val="E74627"/>
-                </a:solidFill>
-                <a:latin typeface="Arial" pitchFamily="34" charset="0"/>
-                <a:ea typeface="Arial" pitchFamily="34" charset="-122"/>
-                <a:cs typeface="Arial" pitchFamily="34" charset="-120"/>
-              </a:rPr>
-              <a:t>02</a:t>
-            </a:r>
-            <a:endParaRPr lang="en-US" sz="3100" dirty="0"/>
-          </a:p>
-        </p:txBody>
-      </p:sp>
-      <p:sp>
-        <p:nvSpPr>
-          <p:cNvPr id="10" name="prompt_menu-text-9"/>
-          <p:cNvSpPr/>
-          <p:nvPr/>
-        </p:nvSpPr>
-        <p:spPr>
-          <a:xfrm>
-            <a:off x="1536700" y="3733800"/>
-            <a:ext cx="6248400" cy="812800"/>
-          </a:xfrm>
-          <a:prstGeom prst="rect">
-            <a:avLst/>
-          </a:prstGeom>
-          <a:noFill/>
-          <a:ln/>
-        </p:spPr>
-        <p:txBody>
-          <a:bodyPr wrap="square" lIns="0" tIns="0" rIns="0" bIns="0" rtlCol="0" anchor="t"/>
-          <a:lstStyle/>
-          <a:p>
-            <a:pPr algn="l" indent="0" marL="0">
-              <a:lnSpc>
-                <a:spcPts val="2990"/>
-              </a:lnSpc>
-              <a:buNone/>
-            </a:pPr>
-            <a:r>
-              <a:rPr lang="en-US" altLang="en-US" sz="2600" dirty="0">
-                <a:solidFill>
-                  <a:srgbClr val="111111"/>
-                </a:solidFill>
-                <a:latin typeface="Arial" pitchFamily="34" charset="0"/>
-                <a:ea typeface="Arial" pitchFamily="34" charset="-122"/>
-                <a:cs typeface="Arial" pitchFamily="34" charset="-120"/>
-              </a:rPr>
-              <a:t>Turn an HKEAA briefing into revision-teaching notes</a:t>
-            </a:r>
-            <a:endParaRPr lang="en-US" sz="2600" dirty="0"/>
-          </a:p>
-        </p:txBody>
-      </p:sp>
-      <p:sp>
-        <p:nvSpPr>
-          <p:cNvPr id="11" name="prompt_menu-shape-10"/>
-          <p:cNvSpPr/>
-          <p:nvPr/>
-        </p:nvSpPr>
-        <p:spPr>
-          <a:xfrm>
-            <a:off x="762000" y="4622800"/>
-            <a:ext cx="6985000" cy="9144"/>
-          </a:xfrm>
-          <a:prstGeom prst="line">
-            <a:avLst/>
-          </a:prstGeom>
-          <a:ln w="12700">
-            <a:solidFill>
-              <a:srgbClr val="CCCCC5"/>
-            </a:solidFill>
-            <a:prstDash val="solid"/>
-          </a:ln>
-        </p:spPr>
-      </p:sp>
-      <p:sp>
-        <p:nvSpPr>
-          <p:cNvPr id="12" name="prompt_menu-text-11"/>
-          <p:cNvSpPr/>
-          <p:nvPr/>
-        </p:nvSpPr>
-        <p:spPr>
-          <a:xfrm>
-            <a:off x="762000" y="4775200"/>
-            <a:ext cx="762000" cy="558800"/>
-          </a:xfrm>
-          <a:prstGeom prst="rect">
-            <a:avLst/>
-          </a:prstGeom>
-          <a:noFill/>
-          <a:ln/>
-        </p:spPr>
-        <p:txBody>
-          <a:bodyPr wrap="square" lIns="0" tIns="0" rIns="0" bIns="0" rtlCol="0" anchor="t"/>
-          <a:lstStyle/>
-          <a:p>
-            <a:pPr algn="l" indent="0" marL="0">
-              <a:buNone/>
-            </a:pPr>
-            <a:r>
-              <a:rPr lang="en-US" altLang="en-US" sz="3100" b="1" dirty="0">
-                <a:solidFill>
-                  <a:srgbClr val="E74627"/>
-                </a:solidFill>
-                <a:latin typeface="Arial" pitchFamily="34" charset="0"/>
-                <a:ea typeface="Arial" pitchFamily="34" charset="-122"/>
-                <a:cs typeface="Arial" pitchFamily="34" charset="-120"/>
-              </a:rPr>
-              <a:t>03</a:t>
-            </a:r>
-            <a:endParaRPr lang="en-US" sz="3100" dirty="0"/>
-          </a:p>
-        </p:txBody>
-      </p:sp>
-      <p:sp>
-        <p:nvSpPr>
-          <p:cNvPr id="13" name="prompt_menu-text-12"/>
-          <p:cNvSpPr/>
-          <p:nvPr/>
-        </p:nvSpPr>
-        <p:spPr>
-          <a:xfrm>
-            <a:off x="1536700" y="4749800"/>
-            <a:ext cx="6248400" cy="812800"/>
-          </a:xfrm>
-          <a:prstGeom prst="rect">
-            <a:avLst/>
-          </a:prstGeom>
-          <a:noFill/>
-          <a:ln/>
-        </p:spPr>
-        <p:txBody>
-          <a:bodyPr wrap="square" lIns="0" tIns="0" rIns="0" bIns="0" rtlCol="0" anchor="t"/>
-          <a:lstStyle/>
-          <a:p>
-            <a:pPr algn="l" indent="0" marL="0">
-              <a:lnSpc>
-                <a:spcPts val="2990"/>
-              </a:lnSpc>
-              <a:buNone/>
-            </a:pPr>
-            <a:r>
-              <a:rPr lang="en-US" altLang="en-US" sz="2600" dirty="0">
-                <a:solidFill>
-                  <a:srgbClr val="111111"/>
-                </a:solidFill>
-                <a:latin typeface="Arial" pitchFamily="34" charset="0"/>
-                <a:ea typeface="Arial" pitchFamily="34" charset="-122"/>
-                <a:cs typeface="Arial" pitchFamily="34" charset="-120"/>
-              </a:rPr>
-              <a:t>Plan an HKDSE lesson with an exit ticket</a:t>
-            </a:r>
-            <a:endParaRPr lang="en-US" sz="2600" dirty="0"/>
-          </a:p>
-        </p:txBody>
-      </p:sp>
-      <p:sp>
-        <p:nvSpPr>
-          <p:cNvPr id="14" name="prompt_menu-shape-13"/>
-          <p:cNvSpPr/>
-          <p:nvPr/>
-        </p:nvSpPr>
-        <p:spPr>
-          <a:xfrm>
-            <a:off x="762000" y="5638800"/>
-            <a:ext cx="6985000" cy="9144"/>
-          </a:xfrm>
-          <a:prstGeom prst="line">
-            <a:avLst/>
-          </a:prstGeom>
-          <a:ln w="12700">
-            <a:solidFill>
-              <a:srgbClr val="CCCCC5"/>
-            </a:solidFill>
-            <a:prstDash val="solid"/>
-          </a:ln>
-        </p:spPr>
-      </p:sp>
-      <p:sp>
-        <p:nvSpPr>
-          <p:cNvPr id="15" name="prompt_menu-text-14"/>
-          <p:cNvSpPr/>
-          <p:nvPr/>
-        </p:nvSpPr>
-        <p:spPr>
-          <a:xfrm>
-            <a:off x="762000" y="5791200"/>
-            <a:ext cx="762000" cy="558800"/>
-          </a:xfrm>
-          <a:prstGeom prst="rect">
-            <a:avLst/>
-          </a:prstGeom>
-          <a:noFill/>
-          <a:ln/>
-        </p:spPr>
-        <p:txBody>
-          <a:bodyPr wrap="square" lIns="0" tIns="0" rIns="0" bIns="0" rtlCol="0" anchor="t"/>
-          <a:lstStyle/>
-          <a:p>
-            <a:pPr algn="l" indent="0" marL="0">
-              <a:buNone/>
-            </a:pPr>
-            <a:r>
-              <a:rPr lang="en-US" altLang="en-US" sz="3100" b="1" dirty="0">
-                <a:solidFill>
-                  <a:srgbClr val="E74627"/>
-                </a:solidFill>
-                <a:latin typeface="Arial" pitchFamily="34" charset="0"/>
-                <a:ea typeface="Arial" pitchFamily="34" charset="-122"/>
-                <a:cs typeface="Arial" pitchFamily="34" charset="-120"/>
-              </a:rPr>
-              <a:t>04</a:t>
-            </a:r>
-            <a:endParaRPr lang="en-US" sz="3100" dirty="0"/>
-          </a:p>
-        </p:txBody>
-      </p:sp>
-      <p:sp>
-        <p:nvSpPr>
-          <p:cNvPr id="16" name="prompt_menu-text-15"/>
-          <p:cNvSpPr/>
-          <p:nvPr/>
-        </p:nvSpPr>
-        <p:spPr>
-          <a:xfrm>
-            <a:off x="1536700" y="5765800"/>
-            <a:ext cx="6248400" cy="812800"/>
-          </a:xfrm>
-          <a:prstGeom prst="rect">
-            <a:avLst/>
-          </a:prstGeom>
-          <a:noFill/>
-          <a:ln/>
-        </p:spPr>
-        <p:txBody>
-          <a:bodyPr wrap="square" lIns="0" tIns="0" rIns="0" bIns="0" rtlCol="0" anchor="t"/>
-          <a:lstStyle/>
-          <a:p>
-            <a:pPr algn="l" indent="0" marL="0">
-              <a:lnSpc>
-                <a:spcPts val="2990"/>
-              </a:lnSpc>
-              <a:buNone/>
-            </a:pPr>
-            <a:r>
-              <a:rPr lang="en-US" altLang="en-US" sz="2600" dirty="0">
-                <a:solidFill>
-                  <a:srgbClr val="111111"/>
-                </a:solidFill>
-                <a:latin typeface="Arial" pitchFamily="34" charset="0"/>
-                <a:ea typeface="Arial" pitchFamily="34" charset="-122"/>
-                <a:cs typeface="Arial" pitchFamily="34" charset="-120"/>
-              </a:rPr>
-              <a:t>Support different levels—keep the same learning goal</a:t>
-            </a:r>
-            <a:endParaRPr lang="en-US" sz="2600" dirty="0"/>
-          </a:p>
-        </p:txBody>
-      </p:sp>
-      <p:sp>
-        <p:nvSpPr>
-          <p:cNvPr id="17" name="prompt_menu-shape-16"/>
-          <p:cNvSpPr/>
-          <p:nvPr/>
-        </p:nvSpPr>
-        <p:spPr>
-          <a:xfrm>
-            <a:off x="762000" y="6654800"/>
-            <a:ext cx="6985000" cy="9144"/>
-          </a:xfrm>
-          <a:prstGeom prst="line">
-            <a:avLst/>
-          </a:prstGeom>
-          <a:ln w="12700">
-            <a:solidFill>
-              <a:srgbClr val="CCCCC5"/>
-            </a:solidFill>
-            <a:prstDash val="solid"/>
-          </a:ln>
-        </p:spPr>
-      </p:sp>
-      <p:sp>
-        <p:nvSpPr>
-          <p:cNvPr id="18" name="prompt_menu-text-17"/>
-          <p:cNvSpPr/>
-          <p:nvPr/>
-        </p:nvSpPr>
-        <p:spPr>
-          <a:xfrm>
-            <a:off x="762000" y="6807200"/>
-            <a:ext cx="762000" cy="558800"/>
-          </a:xfrm>
-          <a:prstGeom prst="rect">
-            <a:avLst/>
-          </a:prstGeom>
-          <a:noFill/>
-          <a:ln/>
-        </p:spPr>
-        <p:txBody>
-          <a:bodyPr wrap="square" lIns="0" tIns="0" rIns="0" bIns="0" rtlCol="0" anchor="t"/>
-          <a:lstStyle/>
-          <a:p>
-            <a:pPr algn="l" indent="0" marL="0">
-              <a:buNone/>
-            </a:pPr>
-            <a:r>
-              <a:rPr lang="en-US" altLang="en-US" sz="3100" b="1" dirty="0">
-                <a:solidFill>
-                  <a:srgbClr val="E74627"/>
-                </a:solidFill>
-                <a:latin typeface="Arial" pitchFamily="34" charset="0"/>
-                <a:ea typeface="Arial" pitchFamily="34" charset="-122"/>
-                <a:cs typeface="Arial" pitchFamily="34" charset="-120"/>
-              </a:rPr>
-              <a:t>05</a:t>
-            </a:r>
-            <a:endParaRPr lang="en-US" sz="3100" dirty="0"/>
-          </a:p>
-        </p:txBody>
-      </p:sp>
-      <p:sp>
-        <p:nvSpPr>
-          <p:cNvPr id="19" name="prompt_menu-text-18"/>
-          <p:cNvSpPr/>
-          <p:nvPr/>
-        </p:nvSpPr>
-        <p:spPr>
-          <a:xfrm>
-            <a:off x="1536700" y="6781800"/>
-            <a:ext cx="6248400" cy="812800"/>
-          </a:xfrm>
-          <a:prstGeom prst="rect">
-            <a:avLst/>
-          </a:prstGeom>
-          <a:noFill/>
-          <a:ln/>
-        </p:spPr>
-        <p:txBody>
-          <a:bodyPr wrap="square" lIns="0" tIns="0" rIns="0" bIns="0" rtlCol="0" anchor="t"/>
-          <a:lstStyle/>
-          <a:p>
-            <a:pPr algn="l" indent="0" marL="0">
-              <a:lnSpc>
-                <a:spcPts val="2990"/>
-              </a:lnSpc>
-              <a:buNone/>
-            </a:pPr>
-            <a:r>
-              <a:rPr lang="en-US" altLang="en-US" sz="2600" dirty="0">
-                <a:solidFill>
-                  <a:srgbClr val="111111"/>
-                </a:solidFill>
-                <a:latin typeface="Arial" pitchFamily="34" charset="0"/>
-                <a:ea typeface="Arial" pitchFamily="34" charset="-122"/>
-                <a:cs typeface="Arial" pitchFamily="34" charset="-120"/>
-              </a:rPr>
-              <a:t>Draft HKDSE-style practice and a separate answer key</a:t>
-            </a:r>
-            <a:endParaRPr lang="en-US" sz="2600" dirty="0"/>
-          </a:p>
-        </p:txBody>
-      </p:sp>
-      <p:sp>
-        <p:nvSpPr>
-          <p:cNvPr id="20" name="prompt_menu-text-19"/>
-          <p:cNvSpPr/>
-          <p:nvPr/>
-        </p:nvSpPr>
-        <p:spPr>
-          <a:xfrm>
-            <a:off x="8585200" y="2743200"/>
-            <a:ext cx="762000" cy="558800"/>
-          </a:xfrm>
-          <a:prstGeom prst="rect">
-            <a:avLst/>
-          </a:prstGeom>
-          <a:noFill/>
-          <a:ln/>
-        </p:spPr>
-        <p:txBody>
-          <a:bodyPr wrap="square" lIns="0" tIns="0" rIns="0" bIns="0" rtlCol="0" anchor="t"/>
-          <a:lstStyle/>
-          <a:p>
-            <a:pPr algn="l" indent="0" marL="0">
-              <a:buNone/>
-            </a:pPr>
-            <a:r>
-              <a:rPr lang="en-US" altLang="en-US" sz="3100" b="1" dirty="0">
-                <a:solidFill>
-                  <a:srgbClr val="E74627"/>
-                </a:solidFill>
-                <a:latin typeface="Arial" pitchFamily="34" charset="0"/>
-                <a:ea typeface="Arial" pitchFamily="34" charset="-122"/>
-                <a:cs typeface="Arial" pitchFamily="34" charset="-120"/>
-              </a:rPr>
-              <a:t>06</a:t>
-            </a:r>
-            <a:endParaRPr lang="en-US" sz="3100" dirty="0"/>
-          </a:p>
-        </p:txBody>
-      </p:sp>
-      <p:sp>
-        <p:nvSpPr>
-          <p:cNvPr id="21" name="prompt_menu-text-20"/>
-          <p:cNvSpPr/>
-          <p:nvPr/>
-        </p:nvSpPr>
-        <p:spPr>
-          <a:xfrm>
-            <a:off x="9359900" y="2717800"/>
-            <a:ext cx="6134100" cy="812800"/>
-          </a:xfrm>
-          <a:prstGeom prst="rect">
-            <a:avLst/>
-          </a:prstGeom>
-          <a:noFill/>
-          <a:ln/>
-        </p:spPr>
-        <p:txBody>
-          <a:bodyPr wrap="square" lIns="0" tIns="0" rIns="0" bIns="0" rtlCol="0" anchor="t"/>
-          <a:lstStyle/>
-          <a:p>
-            <a:pPr algn="l" indent="0" marL="0">
-              <a:lnSpc>
-                <a:spcPts val="2990"/>
-              </a:lnSpc>
-              <a:buNone/>
-            </a:pPr>
-            <a:r>
-              <a:rPr lang="en-US" altLang="en-US" sz="2600" dirty="0">
-                <a:solidFill>
-                  <a:srgbClr val="111111"/>
-                </a:solidFill>
-                <a:latin typeface="Arial" pitchFamily="34" charset="0"/>
-                <a:ea typeface="Arial" pitchFamily="34" charset="-122"/>
-                <a:cs typeface="Arial" pitchFamily="34" charset="-120"/>
-              </a:rPr>
-              <a:t>Turn fictional errors into feedback and reteaching</a:t>
-            </a:r>
-            <a:endParaRPr lang="en-US" sz="2600" dirty="0"/>
-          </a:p>
-        </p:txBody>
-      </p:sp>
-      <p:sp>
-        <p:nvSpPr>
-          <p:cNvPr id="22" name="prompt_menu-shape-21"/>
-          <p:cNvSpPr/>
-          <p:nvPr/>
-        </p:nvSpPr>
-        <p:spPr>
-          <a:xfrm>
-            <a:off x="8585200" y="3606800"/>
-            <a:ext cx="6908800" cy="9144"/>
-          </a:xfrm>
-          <a:prstGeom prst="line">
-            <a:avLst/>
-          </a:prstGeom>
-          <a:ln w="12700">
-            <a:solidFill>
-              <a:srgbClr val="CCCCC5"/>
-            </a:solidFill>
-            <a:prstDash val="solid"/>
-          </a:ln>
-        </p:spPr>
-      </p:sp>
-      <p:sp>
-        <p:nvSpPr>
-          <p:cNvPr id="23" name="prompt_menu-text-22"/>
-          <p:cNvSpPr/>
-          <p:nvPr/>
-        </p:nvSpPr>
-        <p:spPr>
-          <a:xfrm>
-            <a:off x="8585200" y="3759200"/>
-            <a:ext cx="762000" cy="558800"/>
-          </a:xfrm>
-          <a:prstGeom prst="rect">
-            <a:avLst/>
-          </a:prstGeom>
-          <a:noFill/>
-          <a:ln/>
-        </p:spPr>
-        <p:txBody>
-          <a:bodyPr wrap="square" lIns="0" tIns="0" rIns="0" bIns="0" rtlCol="0" anchor="t"/>
-          <a:lstStyle/>
-          <a:p>
-            <a:pPr algn="l" indent="0" marL="0">
-              <a:buNone/>
-            </a:pPr>
-            <a:r>
-              <a:rPr lang="en-US" altLang="en-US" sz="3100" b="1" dirty="0">
-                <a:solidFill>
-                  <a:srgbClr val="E74627"/>
-                </a:solidFill>
-                <a:latin typeface="Arial" pitchFamily="34" charset="0"/>
-                <a:ea typeface="Arial" pitchFamily="34" charset="-122"/>
-                <a:cs typeface="Arial" pitchFamily="34" charset="-120"/>
-              </a:rPr>
-              <a:t>07</a:t>
-            </a:r>
-            <a:endParaRPr lang="en-US" sz="3100" dirty="0"/>
-          </a:p>
-        </p:txBody>
-      </p:sp>
-      <p:sp>
-        <p:nvSpPr>
-          <p:cNvPr id="24" name="prompt_menu-text-23"/>
-          <p:cNvSpPr/>
-          <p:nvPr/>
-        </p:nvSpPr>
-        <p:spPr>
-          <a:xfrm>
-            <a:off x="9359900" y="3733800"/>
-            <a:ext cx="6134100" cy="812800"/>
-          </a:xfrm>
-          <a:prstGeom prst="rect">
-            <a:avLst/>
-          </a:prstGeom>
-          <a:noFill/>
-          <a:ln/>
-        </p:spPr>
-        <p:txBody>
-          <a:bodyPr wrap="square" lIns="0" tIns="0" rIns="0" bIns="0" rtlCol="0" anchor="t"/>
-          <a:lstStyle/>
-          <a:p>
-            <a:pPr algn="l" indent="0" marL="0">
-              <a:lnSpc>
-                <a:spcPts val="2990"/>
-              </a:lnSpc>
-              <a:buNone/>
-            </a:pPr>
-            <a:r>
-              <a:rPr lang="en-US" altLang="en-US" sz="2600" dirty="0">
-                <a:solidFill>
-                  <a:srgbClr val="111111"/>
-                </a:solidFill>
-                <a:latin typeface="Arial" pitchFamily="34" charset="0"/>
-                <a:ea typeface="Arial" pitchFamily="34" charset="-122"/>
-                <a:cs typeface="Arial" pitchFamily="34" charset="-120"/>
-              </a:rPr>
-              <a:t>Audit a teaching or assessment draft before use</a:t>
-            </a:r>
-            <a:endParaRPr lang="en-US" sz="2600" dirty="0"/>
-          </a:p>
-        </p:txBody>
-      </p:sp>
-      <p:sp>
-        <p:nvSpPr>
-          <p:cNvPr id="25" name="prompt_menu-shape-24"/>
-          <p:cNvSpPr/>
-          <p:nvPr/>
-        </p:nvSpPr>
-        <p:spPr>
-          <a:xfrm>
-            <a:off x="8585200" y="4622800"/>
-            <a:ext cx="6908800" cy="9144"/>
-          </a:xfrm>
-          <a:prstGeom prst="line">
-            <a:avLst/>
-          </a:prstGeom>
-          <a:ln w="12700">
-            <a:solidFill>
-              <a:srgbClr val="CCCCC5"/>
-            </a:solidFill>
-            <a:prstDash val="solid"/>
-          </a:ln>
-        </p:spPr>
-      </p:sp>
-      <p:sp>
-        <p:nvSpPr>
-          <p:cNvPr id="26" name="prompt_menu-text-25"/>
-          <p:cNvSpPr/>
-          <p:nvPr/>
-        </p:nvSpPr>
-        <p:spPr>
-          <a:xfrm>
-            <a:off x="8585200" y="4775200"/>
-            <a:ext cx="762000" cy="558800"/>
-          </a:xfrm>
-          <a:prstGeom prst="rect">
-            <a:avLst/>
-          </a:prstGeom>
-          <a:noFill/>
-          <a:ln/>
-        </p:spPr>
-        <p:txBody>
-          <a:bodyPr wrap="square" lIns="0" tIns="0" rIns="0" bIns="0" rtlCol="0" anchor="t"/>
-          <a:lstStyle/>
-          <a:p>
-            <a:pPr algn="l" indent="0" marL="0">
-              <a:buNone/>
-            </a:pPr>
-            <a:r>
-              <a:rPr lang="en-US" altLang="en-US" sz="3100" b="1" dirty="0">
-                <a:solidFill>
-                  <a:srgbClr val="E74627"/>
-                </a:solidFill>
-                <a:latin typeface="Arial" pitchFamily="34" charset="0"/>
-                <a:ea typeface="Arial" pitchFamily="34" charset="-122"/>
-                <a:cs typeface="Arial" pitchFamily="34" charset="-120"/>
-              </a:rPr>
-              <a:t>08</a:t>
-            </a:r>
-            <a:endParaRPr lang="en-US" sz="3100" dirty="0"/>
-          </a:p>
-        </p:txBody>
-      </p:sp>
-      <p:sp>
-        <p:nvSpPr>
-          <p:cNvPr id="27" name="prompt_menu-text-26"/>
-          <p:cNvSpPr/>
-          <p:nvPr/>
-        </p:nvSpPr>
-        <p:spPr>
-          <a:xfrm>
-            <a:off x="9359900" y="4749800"/>
-            <a:ext cx="6134100" cy="812800"/>
-          </a:xfrm>
-          <a:prstGeom prst="rect">
-            <a:avLst/>
-          </a:prstGeom>
-          <a:noFill/>
-          <a:ln/>
-        </p:spPr>
-        <p:txBody>
-          <a:bodyPr wrap="square" lIns="0" tIns="0" rIns="0" bIns="0" rtlCol="0" anchor="t"/>
-          <a:lstStyle/>
-          <a:p>
-            <a:pPr algn="l" indent="0" marL="0">
-              <a:lnSpc>
-                <a:spcPts val="2990"/>
-              </a:lnSpc>
-              <a:buNone/>
-            </a:pPr>
-            <a:r>
-              <a:rPr lang="en-US" altLang="en-US" sz="2600" dirty="0">
-                <a:solidFill>
-                  <a:srgbClr val="111111"/>
-                </a:solidFill>
-                <a:latin typeface="Arial" pitchFamily="34" charset="0"/>
-                <a:ea typeface="Arial" pitchFamily="34" charset="-122"/>
-                <a:cs typeface="Arial" pitchFamily="34" charset="-120"/>
-              </a:rPr>
-              <a:t>Turn a long EDB document into a staff briefing</a:t>
-            </a:r>
-            <a:endParaRPr lang="en-US" sz="2600" dirty="0"/>
-          </a:p>
-        </p:txBody>
-      </p:sp>
-      <p:sp>
-        <p:nvSpPr>
-          <p:cNvPr id="28" name="prompt_menu-shape-27"/>
-          <p:cNvSpPr/>
-          <p:nvPr/>
-        </p:nvSpPr>
-        <p:spPr>
-          <a:xfrm>
-            <a:off x="8585200" y="5638800"/>
-            <a:ext cx="6908800" cy="9144"/>
-          </a:xfrm>
-          <a:prstGeom prst="line">
-            <a:avLst/>
-          </a:prstGeom>
-          <a:ln w="12700">
-            <a:solidFill>
-              <a:srgbClr val="CCCCC5"/>
-            </a:solidFill>
-            <a:prstDash val="solid"/>
-          </a:ln>
-        </p:spPr>
-      </p:sp>
-      <p:sp>
-        <p:nvSpPr>
-          <p:cNvPr id="29" name="prompt_menu-text-28"/>
-          <p:cNvSpPr/>
-          <p:nvPr/>
-        </p:nvSpPr>
-        <p:spPr>
-          <a:xfrm>
-            <a:off x="8585200" y="5791200"/>
-            <a:ext cx="762000" cy="558800"/>
-          </a:xfrm>
-          <a:prstGeom prst="rect">
-            <a:avLst/>
-          </a:prstGeom>
-          <a:noFill/>
-          <a:ln/>
-        </p:spPr>
-        <p:txBody>
-          <a:bodyPr wrap="square" lIns="0" tIns="0" rIns="0" bIns="0" rtlCol="0" anchor="t"/>
-          <a:lstStyle/>
-          <a:p>
-            <a:pPr algn="l" indent="0" marL="0">
-              <a:buNone/>
-            </a:pPr>
-            <a:r>
-              <a:rPr lang="en-US" altLang="en-US" sz="3100" b="1" dirty="0">
-                <a:solidFill>
-                  <a:srgbClr val="E74627"/>
-                </a:solidFill>
-                <a:latin typeface="Arial" pitchFamily="34" charset="0"/>
-                <a:ea typeface="Arial" pitchFamily="34" charset="-122"/>
-                <a:cs typeface="Arial" pitchFamily="34" charset="-120"/>
-              </a:rPr>
-              <a:t>09</a:t>
-            </a:r>
-            <a:endParaRPr lang="en-US" sz="3100" dirty="0"/>
-          </a:p>
-        </p:txBody>
-      </p:sp>
-      <p:sp>
-        <p:nvSpPr>
-          <p:cNvPr id="30" name="prompt_menu-text-29"/>
-          <p:cNvSpPr/>
-          <p:nvPr/>
-        </p:nvSpPr>
-        <p:spPr>
-          <a:xfrm>
-            <a:off x="9359900" y="5765800"/>
-            <a:ext cx="6134100" cy="812800"/>
-          </a:xfrm>
-          <a:prstGeom prst="rect">
-            <a:avLst/>
-          </a:prstGeom>
-          <a:noFill/>
-          <a:ln/>
-        </p:spPr>
-        <p:txBody>
-          <a:bodyPr wrap="square" lIns="0" tIns="0" rIns="0" bIns="0" rtlCol="0" anchor="t"/>
-          <a:lstStyle/>
-          <a:p>
-            <a:pPr algn="l" indent="0" marL="0">
-              <a:lnSpc>
-                <a:spcPts val="2990"/>
-              </a:lnSpc>
-              <a:buNone/>
-            </a:pPr>
-            <a:r>
-              <a:rPr lang="en-US" altLang="en-US" sz="2600" dirty="0">
-                <a:solidFill>
-                  <a:srgbClr val="111111"/>
-                </a:solidFill>
-                <a:latin typeface="Arial" pitchFamily="34" charset="0"/>
-                <a:ea typeface="Arial" pitchFamily="34" charset="-122"/>
-                <a:cs typeface="Arial" pitchFamily="34" charset="-120"/>
-              </a:rPr>
-              <a:t>Extract actions, dates and unanswered questions</a:t>
-            </a:r>
-            <a:endParaRPr lang="en-US" sz="2600" dirty="0"/>
-          </a:p>
-        </p:txBody>
-      </p:sp>
-      <p:sp>
-        <p:nvSpPr>
-          <p:cNvPr id="31" name="prompt_menu-shape-30"/>
-          <p:cNvSpPr/>
-          <p:nvPr/>
-        </p:nvSpPr>
-        <p:spPr>
-          <a:xfrm>
-            <a:off x="8585200" y="6654800"/>
-            <a:ext cx="6908800" cy="9144"/>
-          </a:xfrm>
-          <a:prstGeom prst="line">
-            <a:avLst/>
-          </a:prstGeom>
-          <a:ln w="12700">
-            <a:solidFill>
-              <a:srgbClr val="CCCCC5"/>
-            </a:solidFill>
-            <a:prstDash val="solid"/>
-          </a:ln>
-        </p:spPr>
-      </p:sp>
-      <p:sp>
-        <p:nvSpPr>
-          <p:cNvPr id="32" name="prompt_menu-text-31"/>
-          <p:cNvSpPr/>
-          <p:nvPr/>
-        </p:nvSpPr>
-        <p:spPr>
-          <a:xfrm>
-            <a:off x="8585200" y="6807200"/>
-            <a:ext cx="762000" cy="558800"/>
-          </a:xfrm>
-          <a:prstGeom prst="rect">
-            <a:avLst/>
-          </a:prstGeom>
-          <a:noFill/>
-          <a:ln/>
-        </p:spPr>
-        <p:txBody>
-          <a:bodyPr wrap="square" lIns="0" tIns="0" rIns="0" bIns="0" rtlCol="0" anchor="t"/>
-          <a:lstStyle/>
-          <a:p>
-            <a:pPr algn="l" indent="0" marL="0">
-              <a:buNone/>
-            </a:pPr>
-            <a:r>
-              <a:rPr lang="en-US" altLang="en-US" sz="3100" b="1" dirty="0">
-                <a:solidFill>
-                  <a:srgbClr val="E74627"/>
-                </a:solidFill>
-                <a:latin typeface="Arial" pitchFamily="34" charset="0"/>
-                <a:ea typeface="Arial" pitchFamily="34" charset="-122"/>
-                <a:cs typeface="Arial" pitchFamily="34" charset="-120"/>
-              </a:rPr>
-              <a:t>10</a:t>
-            </a:r>
-            <a:endParaRPr lang="en-US" sz="3100" dirty="0"/>
-          </a:p>
-        </p:txBody>
-      </p:sp>
-      <p:sp>
-        <p:nvSpPr>
-          <p:cNvPr id="33" name="prompt_menu-text-32"/>
-          <p:cNvSpPr/>
-          <p:nvPr/>
-        </p:nvSpPr>
-        <p:spPr>
-          <a:xfrm>
-            <a:off x="9359900" y="6781800"/>
-            <a:ext cx="6134100" cy="812800"/>
-          </a:xfrm>
-          <a:prstGeom prst="rect">
-            <a:avLst/>
-          </a:prstGeom>
-          <a:noFill/>
-          <a:ln/>
-        </p:spPr>
-        <p:txBody>
-          <a:bodyPr wrap="square" lIns="0" tIns="0" rIns="0" bIns="0" rtlCol="0" anchor="t"/>
-          <a:lstStyle/>
-          <a:p>
-            <a:pPr algn="l" indent="0" marL="0">
-              <a:lnSpc>
-                <a:spcPts val="2990"/>
-              </a:lnSpc>
-              <a:buNone/>
-            </a:pPr>
-            <a:r>
-              <a:rPr lang="en-US" altLang="en-US" sz="2600" dirty="0">
-                <a:solidFill>
-                  <a:srgbClr val="111111"/>
-                </a:solidFill>
-                <a:latin typeface="Arial" pitchFamily="34" charset="0"/>
-                <a:ea typeface="Arial" pitchFamily="34" charset="-122"/>
-                <a:cs typeface="Arial" pitchFamily="34" charset="-120"/>
-              </a:rPr>
-              <a:t>Compare official documents: updates or contradictions?</a:t>
-            </a:r>
-            <a:endParaRPr lang="en-US" sz="2600" dirty="0"/>
-          </a:p>
-        </p:txBody>
-      </p:sp>
-      <p:sp>
-        <p:nvSpPr>
-          <p:cNvPr id="34" name="prompt_menu-shape-33"/>
-          <p:cNvSpPr/>
-          <p:nvPr/>
-        </p:nvSpPr>
-        <p:spPr>
-          <a:xfrm>
-            <a:off x="762000" y="8102600"/>
-            <a:ext cx="14732000" cy="9144"/>
-          </a:xfrm>
-          <a:prstGeom prst="line">
-            <a:avLst/>
-          </a:prstGeom>
-          <a:ln w="12700">
-            <a:solidFill>
-              <a:srgbClr val="CCCCC5"/>
-            </a:solidFill>
-            <a:prstDash val="solid"/>
-          </a:ln>
-        </p:spPr>
-      </p:sp>
-      <p:sp>
-        <p:nvSpPr>
-          <p:cNvPr id="35" name="prompt_menu-shape-34"/>
+          <p:cNvPr id="11" name="example_context-shape-10"/>
           <p:cNvSpPr/>
           <p:nvPr/>
         </p:nvSpPr>
@@ -7358,7 +6615,7 @@
       </p:sp>
       <p:pic>
         <p:nvPicPr>
-          <p:cNvPr id="36" name="prompt_menu-image-35" descr="preencoded.png">    </p:cNvPr>
+          <p:cNvPr id="12" name="example_context-image-11" descr="preencoded.png">    </p:cNvPr>
           <p:cNvPicPr>
             <a:picLocks noChangeAspect="1"/>
           </p:cNvPicPr>
@@ -7381,7 +6638,7 @@
       </p:pic>
       <p:sp>
         <p:nvSpPr>
-          <p:cNvPr id="37" name="prompt_menu-text-36"/>
+          <p:cNvPr id="13" name="example_context-text-12"/>
           <p:cNvSpPr/>
           <p:nvPr/>
         </p:nvSpPr>
@@ -7420,7 +6677,7 @@
       </p:sp>
       <p:sp>
         <p:nvSpPr>
-          <p:cNvPr id="38" name="prompt_menu-text-37"/>
+          <p:cNvPr id="14" name="example_context-text-13"/>
           <p:cNvSpPr/>
           <p:nvPr/>
         </p:nvSpPr>
@@ -7459,7 +6716,7 @@
       </p:sp>
       <p:sp>
         <p:nvSpPr>
-          <p:cNvPr id="39" name="prompt_menu-text-38"/>
+          <p:cNvPr id="15" name="example_context-text-14"/>
           <p:cNvSpPr/>
           <p:nvPr/>
         </p:nvSpPr>
@@ -7553,33 +6810,30 @@
       </p:pic>
       <p:sp>
         <p:nvSpPr>
-          <p:cNvPr id="3" name="example_context-text-2"/>
-          <p:cNvSpPr/>
-          <p:nvPr/>
-        </p:nvSpPr>
-        <p:spPr>
-          <a:xfrm>
-            <a:off x="762000" y="889000"/>
-            <a:ext cx="14732000" cy="1651000"/>
-          </a:xfrm>
-          <a:prstGeom prst="rect">
-            <a:avLst/>
-          </a:prstGeom>
-          <a:noFill/>
-          <a:ln/>
-        </p:spPr>
-        <p:txBody>
-          <a:bodyPr wrap="square" lIns="0" tIns="0" rIns="0" bIns="0" rtlCol="0" anchor="t"/>
-          <a:lstStyle/>
-          <a:p>
-            <a:pPr algn="l" indent="0" marL="0">
-              <a:lnSpc>
-                <a:spcPts val="5512"/>
-              </a:lnSpc>
-              <a:buNone/>
-            </a:pPr>
-            <a:r>
-              <a:rPr lang="en-US" altLang="en-US" sz="5200" b="1" dirty="0">
+          <p:cNvPr id="3" name="example_english-text-2"/>
+          <p:cNvSpPr/>
+          <p:nvPr/>
+        </p:nvSpPr>
+        <p:spPr>
+          <a:xfrm>
+            <a:off x="762000" y="952500"/>
+            <a:ext cx="14732000" cy="889000"/>
+          </a:xfrm>
+          <a:prstGeom prst="rect">
+            <a:avLst/>
+          </a:prstGeom>
+          <a:noFill/>
+          <a:ln/>
+        </p:spPr>
+        <p:txBody>
+          <a:bodyPr wrap="square" lIns="0" tIns="0" rIns="0" bIns="0" rtlCol="0" anchor="t"/>
+          <a:lstStyle/>
+          <a:p>
+            <a:pPr algn="l" indent="0" marL="0">
+              <a:buNone/>
+            </a:pPr>
+            <a:r>
+              <a:rPr lang="en-US" altLang="en-US" sz="4800" b="1" dirty="0">
                 <a:solidFill>
                   <a:srgbClr val="111111"/>
                 </a:solidFill>
@@ -7587,19 +6841,10 @@
                 <a:ea typeface="Arial" pitchFamily="34" charset="-122"/>
                 <a:cs typeface="Arial" pitchFamily="34" charset="-120"/>
               </a:rPr>
-              <a:t>Example 1</a:t>
-            </a:r>
-            <a:endParaRPr lang="en-US" sz="5200" dirty="0"/>
-          </a:p>
-          <a:p>
-            <a:pPr algn="l" indent="0" marL="0">
-              <a:lnSpc>
-                <a:spcPts val="5512"/>
-              </a:lnSpc>
-              <a:buNone/>
-            </a:pPr>
-            <a:r>
-              <a:rPr lang="en-US" altLang="en-US" sz="5200" b="1" dirty="0">
+              <a:t>Example </a:t>
+            </a:r>
+            <a:r>
+              <a:rPr lang="en-US" altLang="en-US" sz="4800" b="1" dirty="0">
                 <a:solidFill>
                   <a:srgbClr val="E74627"/>
                 </a:solidFill>
@@ -7607,21 +6852,21 @@
                 <a:ea typeface="Arial" pitchFamily="34" charset="-122"/>
                 <a:cs typeface="Arial" pitchFamily="34" charset="-120"/>
               </a:rPr>
-              <a:t>Check S6 English reading materials.</a:t>
-            </a:r>
-            <a:endParaRPr lang="en-US" sz="5200" dirty="0"/>
-          </a:p>
-        </p:txBody>
-      </p:sp>
-      <p:sp>
-        <p:nvSpPr>
-          <p:cNvPr id="4" name="example_context-shape-3"/>
-          <p:cNvSpPr/>
-          <p:nvPr/>
-        </p:nvSpPr>
-        <p:spPr>
-          <a:xfrm>
-            <a:off x="762000" y="2781300"/>
+              <a:t>/ English prompt</a:t>
+            </a:r>
+            <a:endParaRPr lang="en-US" sz="4800" dirty="0"/>
+          </a:p>
+        </p:txBody>
+      </p:sp>
+      <p:sp>
+        <p:nvSpPr>
+          <p:cNvPr id="4" name="example_english-shape-3"/>
+          <p:cNvSpPr/>
+          <p:nvPr/>
+        </p:nvSpPr>
+        <p:spPr>
+          <a:xfrm>
+            <a:off x="762000" y="2082800"/>
             <a:ext cx="14732000" cy="9144"/>
           </a:xfrm>
           <a:prstGeom prst="line">
@@ -7637,30 +6882,124 @@
       </p:sp>
       <p:sp>
         <p:nvSpPr>
-          <p:cNvPr id="5" name="example_context-text-4"/>
-          <p:cNvSpPr/>
-          <p:nvPr/>
-        </p:nvSpPr>
-        <p:spPr>
-          <a:xfrm>
-            <a:off x="762000" y="3098800"/>
-            <a:ext cx="14732000" cy="495300"/>
-          </a:xfrm>
-          <a:prstGeom prst="rect">
-            <a:avLst/>
-          </a:prstGeom>
-          <a:noFill/>
-          <a:ln/>
-        </p:spPr>
-        <p:txBody>
-          <a:bodyPr wrap="square" lIns="0" tIns="0" rIns="0" bIns="0" rtlCol="0" anchor="t"/>
-          <a:lstStyle/>
-          <a:p>
-            <a:pPr algn="l" indent="0" marL="0">
-              <a:buNone/>
-            </a:pPr>
-            <a:r>
-              <a:rPr lang="en-US" altLang="en-US" sz="2800" b="1" dirty="0">
+          <p:cNvPr id="5" name="example_english-text-4"/>
+          <p:cNvSpPr/>
+          <p:nvPr/>
+        </p:nvSpPr>
+        <p:spPr>
+          <a:xfrm>
+            <a:off x="762000" y="2451100"/>
+            <a:ext cx="14732000" cy="5384800"/>
+          </a:xfrm>
+          <a:prstGeom prst="rect">
+            <a:avLst/>
+          </a:prstGeom>
+          <a:noFill/>
+          <a:ln/>
+        </p:spPr>
+        <p:txBody>
+          <a:bodyPr wrap="square" lIns="0" tIns="0" rIns="0" bIns="0" rtlCol="0" anchor="t"/>
+          <a:lstStyle/>
+          <a:p>
+            <a:pPr algn="l" indent="0" marL="0">
+              <a:lnSpc>
+                <a:spcPts val="3422"/>
+              </a:lnSpc>
+              <a:spcAft>
+                <a:spcPts val="1400"/>
+              </a:spcAft>
+              <a:buNone/>
+            </a:pPr>
+            <a:r>
+              <a:rPr lang="en-US" altLang="en-US" sz="2900" dirty="0">
+                <a:solidFill>
+                  <a:srgbClr val="111111"/>
+                </a:solidFill>
+                <a:latin typeface="Arial" pitchFamily="34" charset="0"/>
+                <a:ea typeface="Arial" pitchFamily="34" charset="-122"/>
+                <a:cs typeface="Arial" pitchFamily="34" charset="-120"/>
+              </a:rPr>
+              <a:t>Compare ‘S6 Reading Revision — teacher notes’ with the selected HKDSE English Language Curriculum and Assessment Guide and assessment framework. Focus on reading comprehension and supporting answers with text evidence.</a:t>
+            </a:r>
+            <a:endParaRPr lang="en-US" sz="2900" dirty="0"/>
+          </a:p>
+          <a:p>
+            <a:pPr algn="l" indent="0" marL="0">
+              <a:lnSpc>
+                <a:spcPts val="3422"/>
+              </a:lnSpc>
+              <a:spcAft>
+                <a:spcPts val="1400"/>
+              </a:spcAft>
+              <a:buNone/>
+            </a:pPr>
+            <a:r>
+              <a:rPr lang="en-US" altLang="en-US" sz="2900" dirty="0">
+                <a:solidFill>
+                  <a:srgbClr val="111111"/>
+                </a:solidFill>
+                <a:latin typeface="Arial" pitchFamily="34" charset="0"/>
+                <a:ea typeface="Arial" pitchFamily="34" charset="-122"/>
+                <a:cs typeface="Arial" pitchFamily="34" charset="-120"/>
+              </a:rPr>
+              <a:t>Use a </a:t>
+            </a:r>
+            <a:r>
+              <a:rPr lang="en-US" altLang="en-US" sz="2900" b="1" dirty="0">
+                <a:solidFill>
+                  <a:srgbClr val="111111"/>
+                </a:solidFill>
+                <a:latin typeface="Arial" pitchFamily="34" charset="0"/>
+                <a:ea typeface="Arial" pitchFamily="34" charset="-122"/>
+                <a:cs typeface="Arial" pitchFamily="34" charset="-120"/>
+              </a:rPr>
+              <a:t>four-column table</a:t>
+            </a:r>
+            <a:r>
+              <a:rPr lang="en-US" altLang="en-US" sz="2900" dirty="0">
+                <a:solidFill>
+                  <a:srgbClr val="111111"/>
+                </a:solidFill>
+                <a:latin typeface="Arial" pitchFamily="34" charset="0"/>
+                <a:ea typeface="Arial" pitchFamily="34" charset="-122"/>
+                <a:cs typeface="Arial" pitchFamily="34" charset="-120"/>
+              </a:rPr>
+              <a:t>: Official objective; Evidence in our notes; Coverage (clear / partial / not found); Suggested improvement. Cite both the guidance and our notes. End with three revision-teaching priorities.</a:t>
+            </a:r>
+            <a:endParaRPr lang="en-US" sz="2900" dirty="0"/>
+          </a:p>
+          <a:p>
+            <a:pPr algn="l" indent="0" marL="0">
+              <a:lnSpc>
+                <a:spcPts val="3422"/>
+              </a:lnSpc>
+              <a:spcAft>
+                <a:spcPts val="1400"/>
+              </a:spcAft>
+              <a:buNone/>
+            </a:pPr>
+            <a:r>
+              <a:rPr lang="en-US" altLang="en-US" sz="2900" dirty="0">
+                <a:solidFill>
+                  <a:srgbClr val="111111"/>
+                </a:solidFill>
+                <a:latin typeface="Arial" pitchFamily="34" charset="0"/>
+                <a:ea typeface="Arial" pitchFamily="34" charset="-122"/>
+                <a:cs typeface="Arial" pitchFamily="34" charset="-120"/>
+              </a:rPr>
+              <a:t>Keep curriculum objectives separate from exam rules. Flag anything not stated in the sources. ‘Not found’ refers only to the selected notes.</a:t>
+            </a:r>
+            <a:endParaRPr lang="en-US" sz="2900" dirty="0"/>
+          </a:p>
+          <a:p>
+            <a:pPr algn="l" indent="0" marL="0">
+              <a:lnSpc>
+                <a:spcPts val="3422"/>
+              </a:lnSpc>
+              <a:buNone/>
+            </a:pPr>
+            <a:r>
+              <a:rPr lang="en-US" altLang="en-US" sz="2900" b="1" dirty="0">
                 <a:solidFill>
                   <a:srgbClr val="E74627"/>
                 </a:solidFill>
@@ -7668,63 +7007,21 @@
                 <a:ea typeface="Arial" pitchFamily="34" charset="-122"/>
                 <a:cs typeface="Arial" pitchFamily="34" charset="-120"/>
               </a:rPr>
-              <a:t>Situation</a:t>
-            </a:r>
-            <a:endParaRPr lang="en-US" sz="2800" dirty="0"/>
-          </a:p>
-        </p:txBody>
-      </p:sp>
-      <p:sp>
-        <p:nvSpPr>
-          <p:cNvPr id="6" name="example_context-text-5"/>
-          <p:cNvSpPr/>
-          <p:nvPr/>
-        </p:nvSpPr>
-        <p:spPr>
-          <a:xfrm>
-            <a:off x="762000" y="3683000"/>
-            <a:ext cx="14732000" cy="1333500"/>
-          </a:xfrm>
-          <a:prstGeom prst="rect">
-            <a:avLst/>
-          </a:prstGeom>
-          <a:noFill/>
-          <a:ln/>
-        </p:spPr>
-        <p:txBody>
-          <a:bodyPr wrap="square" lIns="0" tIns="0" rIns="0" bIns="0" rtlCol="0" anchor="t"/>
-          <a:lstStyle/>
-          <a:p>
-            <a:pPr algn="l" indent="0" marL="0">
-              <a:lnSpc>
-                <a:spcPts val="3540"/>
-              </a:lnSpc>
-              <a:buNone/>
-            </a:pPr>
-            <a:r>
-              <a:rPr lang="en-US" altLang="en-US" sz="3000" dirty="0">
-                <a:solidFill>
-                  <a:srgbClr val="111111"/>
-                </a:solidFill>
-                <a:latin typeface="Arial" pitchFamily="34" charset="0"/>
-                <a:ea typeface="Arial" pitchFamily="34" charset="-122"/>
-                <a:cs typeface="Arial" pitchFamily="34" charset="-120"/>
-              </a:rPr>
-              <a:t>Before planning S6 revision, an English teacher wants to know whether the school’s reading-comprehension notes address the skills identified in the selected official guidance.</a:t>
-            </a:r>
-            <a:endParaRPr lang="en-US" sz="3000" dirty="0"/>
-          </a:p>
-        </p:txBody>
-      </p:sp>
-      <p:sp>
-        <p:nvSpPr>
-          <p:cNvPr id="7" name="example_context-shape-6"/>
-          <p:cNvSpPr/>
-          <p:nvPr/>
-        </p:nvSpPr>
-        <p:spPr>
-          <a:xfrm>
-            <a:off x="762000" y="5295900"/>
+              <a:t>Write in English.</a:t>
+            </a:r>
+            <a:endParaRPr lang="en-US" sz="2900" dirty="0"/>
+          </a:p>
+        </p:txBody>
+      </p:sp>
+      <p:sp>
+        <p:nvSpPr>
+          <p:cNvPr id="6" name="example_english-shape-5"/>
+          <p:cNvSpPr/>
+          <p:nvPr/>
+        </p:nvSpPr>
+        <p:spPr>
+          <a:xfrm>
+            <a:off x="762000" y="8102600"/>
             <a:ext cx="14732000" cy="9144"/>
           </a:xfrm>
           <a:prstGeom prst="line">
@@ -7740,168 +7037,7 @@
       </p:sp>
       <p:sp>
         <p:nvSpPr>
-          <p:cNvPr id="8" name="example_context-text-7"/>
-          <p:cNvSpPr/>
-          <p:nvPr/>
-        </p:nvSpPr>
-        <p:spPr>
-          <a:xfrm>
-            <a:off x="762000" y="5588000"/>
-            <a:ext cx="14732000" cy="508000"/>
-          </a:xfrm>
-          <a:prstGeom prst="rect">
-            <a:avLst/>
-          </a:prstGeom>
-          <a:noFill/>
-          <a:ln/>
-        </p:spPr>
-        <p:txBody>
-          <a:bodyPr wrap="square" lIns="0" tIns="0" rIns="0" bIns="0" rtlCol="0" anchor="t"/>
-          <a:lstStyle/>
-          <a:p>
-            <a:pPr algn="l" indent="0" marL="0">
-              <a:buNone/>
-            </a:pPr>
-            <a:r>
-              <a:rPr lang="en-US" altLang="en-US" sz="2800" b="1" dirty="0">
-                <a:solidFill>
-                  <a:srgbClr val="E74627"/>
-                </a:solidFill>
-                <a:latin typeface="Arial" pitchFamily="34" charset="0"/>
-                <a:ea typeface="Arial" pitchFamily="34" charset="-122"/>
-                <a:cs typeface="Arial" pitchFamily="34" charset="-120"/>
-              </a:rPr>
-              <a:t>Sources to add to Notebook</a:t>
-            </a:r>
-            <a:endParaRPr lang="en-US" sz="2800" dirty="0"/>
-          </a:p>
-        </p:txBody>
-      </p:sp>
-      <p:sp>
-        <p:nvSpPr>
-          <p:cNvPr id="9" name="example_context-text-8"/>
-          <p:cNvSpPr/>
-          <p:nvPr/>
-        </p:nvSpPr>
-        <p:spPr>
-          <a:xfrm>
-            <a:off x="762000" y="6223000"/>
-            <a:ext cx="14732000" cy="1562100"/>
-          </a:xfrm>
-          <a:prstGeom prst="rect">
-            <a:avLst/>
-          </a:prstGeom>
-          <a:noFill/>
-          <a:ln/>
-        </p:spPr>
-        <p:txBody>
-          <a:bodyPr wrap="square" lIns="0" tIns="0" rIns="0" bIns="0" rtlCol="0" anchor="t"/>
-          <a:lstStyle/>
-          <a:p>
-            <a:pPr algn="l" marL="444500" indent="-444500">
-              <a:lnSpc>
-                <a:spcPts val="3500"/>
-              </a:lnSpc>
-              <a:spcBef>
-                <a:spcPts val="10"/>
-              </a:spcBef>
-              <a:spcAft>
-                <a:spcPts val="500"/>
-              </a:spcAft>
-              <a:buSzPct val="100000"/>
-              <a:buChar char="•"/>
-            </a:pPr>
-            <a:r>
-              <a:rPr lang="en-US" altLang="en-US" sz="2800" dirty="0">
-                <a:solidFill>
-                  <a:srgbClr val="111111"/>
-                </a:solidFill>
-                <a:latin typeface="Arial" pitchFamily="34" charset="0"/>
-                <a:ea typeface="Arial" pitchFamily="34" charset="-122"/>
-                <a:cs typeface="Arial" pitchFamily="34" charset="-120"/>
-              </a:rPr>
-              <a:t>English Language Curriculum and Assessment Guide (Secondary 4 - 6)</a:t>
-            </a:r>
-            <a:endParaRPr lang="en-US" sz="2800" dirty="0"/>
-          </a:p>
-          <a:p>
-            <a:pPr algn="l" marL="444500" indent="-444500">
-              <a:lnSpc>
-                <a:spcPts val="3500"/>
-              </a:lnSpc>
-              <a:spcBef>
-                <a:spcPts val="10"/>
-              </a:spcBef>
-              <a:spcAft>
-                <a:spcPts val="500"/>
-              </a:spcAft>
-              <a:buSzPct val="100000"/>
-              <a:buChar char="•"/>
-            </a:pPr>
-            <a:r>
-              <a:rPr lang="en-US" altLang="en-US" sz="2800" dirty="0">
-                <a:solidFill>
-                  <a:srgbClr val="111111"/>
-                </a:solidFill>
-                <a:latin typeface="Arial" pitchFamily="34" charset="0"/>
-                <a:ea typeface="Arial" pitchFamily="34" charset="-122"/>
-                <a:cs typeface="Arial" pitchFamily="34" charset="-120"/>
-              </a:rPr>
-              <a:t>English Language Assessment Framework for HKDSE</a:t>
-            </a:r>
-            <a:endParaRPr lang="en-US" sz="2800" dirty="0"/>
-          </a:p>
-          <a:p>
-            <a:pPr algn="l" marL="444500" indent="-444500">
-              <a:lnSpc>
-                <a:spcPts val="3500"/>
-              </a:lnSpc>
-              <a:spcBef>
-                <a:spcPts val="10"/>
-              </a:spcBef>
-              <a:buSzPct val="100000"/>
-              <a:buChar char="•"/>
-            </a:pPr>
-            <a:r>
-              <a:rPr lang="en-US" altLang="en-US" sz="2800" dirty="0">
-                <a:solidFill>
-                  <a:srgbClr val="111111"/>
-                </a:solidFill>
-                <a:latin typeface="Arial" pitchFamily="34" charset="0"/>
-                <a:ea typeface="Arial" pitchFamily="34" charset="-122"/>
-                <a:cs typeface="Arial" pitchFamily="34" charset="-120"/>
-              </a:rPr>
-              <a:t>The related reading notes</a:t>
-            </a:r>
-            <a:endParaRPr lang="en-US" sz="2800" dirty="0"/>
-          </a:p>
-        </p:txBody>
-      </p:sp>
-      <p:sp>
-        <p:nvSpPr>
-          <p:cNvPr id="10" name="example_context-shape-9"/>
-          <p:cNvSpPr/>
-          <p:nvPr/>
-        </p:nvSpPr>
-        <p:spPr>
-          <a:xfrm>
-            <a:off x="762000" y="8102600"/>
-            <a:ext cx="14732000" cy="9144"/>
-          </a:xfrm>
-          <a:prstGeom prst="line">
-            <a:avLst/>
-          </a:prstGeom>
-          <a:ln w="12700">
-            <a:solidFill>
-              <a:srgbClr val="CCCCC5"/>
-            </a:solidFill>
-            <a:prstDash val="solid"/>
-          </a:ln>
-        </p:spPr>
-      </p:sp>
-      <p:sp>
-        <p:nvSpPr>
-          <p:cNvPr id="11" name="example_context-shape-10"/>
+          <p:cNvPr id="7" name="example_english-shape-6"/>
           <p:cNvSpPr/>
           <p:nvPr/>
         </p:nvSpPr>
@@ -7925,7 +7061,7 @@
       </p:sp>
       <p:pic>
         <p:nvPicPr>
-          <p:cNvPr id="12" name="example_context-image-11" descr="preencoded.png">    </p:cNvPr>
+          <p:cNvPr id="8" name="example_english-image-7" descr="preencoded.png">    </p:cNvPr>
           <p:cNvPicPr>
             <a:picLocks noChangeAspect="1"/>
           </p:cNvPicPr>
@@ -7948,7 +7084,7 @@
       </p:pic>
       <p:sp>
         <p:nvSpPr>
-          <p:cNvPr id="13" name="example_context-text-12"/>
+          <p:cNvPr id="9" name="example_english-text-8"/>
           <p:cNvSpPr/>
           <p:nvPr/>
         </p:nvSpPr>
@@ -7987,7 +7123,7 @@
       </p:sp>
       <p:sp>
         <p:nvSpPr>
-          <p:cNvPr id="14" name="example_context-text-13"/>
+          <p:cNvPr id="10" name="example_english-text-9"/>
           <p:cNvSpPr/>
           <p:nvPr/>
         </p:nvSpPr>
@@ -8026,7 +7162,7 @@
       </p:sp>
       <p:sp>
         <p:nvSpPr>
-          <p:cNvPr id="15" name="example_context-text-14"/>
+          <p:cNvPr id="11" name="example_english-text-10"/>
           <p:cNvSpPr/>
           <p:nvPr/>
         </p:nvSpPr>
@@ -8120,7 +7256,7 @@
       </p:pic>
       <p:sp>
         <p:nvSpPr>
-          <p:cNvPr id="3" name="example_english-text-2"/>
+          <p:cNvPr id="3" name="example_chinese-text-2"/>
           <p:cNvSpPr/>
           <p:nvPr/>
         </p:nvSpPr>
@@ -8151,18 +7287,18 @@
                 <a:ea typeface="Arial" pitchFamily="34" charset="-122"/>
                 <a:cs typeface="Arial" pitchFamily="34" charset="-120"/>
               </a:rPr>
-              <a:t>Example 1 </a:t>
+              <a:t>Example </a:t>
             </a:r>
             <a:r>
               <a:rPr lang="en-US" altLang="en-US" sz="4800" b="1" dirty="0">
                 <a:solidFill>
                   <a:srgbClr val="E74627"/>
                 </a:solidFill>
-                <a:latin typeface="Arial" pitchFamily="34" charset="0"/>
-                <a:ea typeface="Arial" pitchFamily="34" charset="-122"/>
-                <a:cs typeface="Arial" pitchFamily="34" charset="-120"/>
-              </a:rPr>
-              <a:t>/ English prompt</a:t>
+                <a:latin typeface="Microsoft JhengHei" pitchFamily="34" charset="0"/>
+                <a:ea typeface="Microsoft JhengHei" pitchFamily="34" charset="-122"/>
+                <a:cs typeface="Microsoft JhengHei" pitchFamily="34" charset="-120"/>
+              </a:rPr>
+              <a:t>/ 繁體中文提示詞</a:t>
             </a:r>
             <a:endParaRPr lang="en-US" sz="4800" dirty="0"/>
           </a:p>
@@ -8170,7 +7306,7 @@
       </p:sp>
       <p:sp>
         <p:nvSpPr>
-          <p:cNvPr id="4" name="example_english-shape-3"/>
+          <p:cNvPr id="4" name="example_chinese-shape-3"/>
           <p:cNvSpPr/>
           <p:nvPr/>
         </p:nvSpPr>
@@ -8192,7 +7328,7 @@
       </p:sp>
       <p:sp>
         <p:nvSpPr>
-          <p:cNvPr id="5" name="example_english-text-4"/>
+          <p:cNvPr id="5" name="example_chinese-text-4"/>
           <p:cNvSpPr/>
           <p:nvPr/>
         </p:nvSpPr>
@@ -8213,119 +7349,119 @@
           <a:p>
             <a:pPr algn="l" indent="0" marL="0">
               <a:lnSpc>
-                <a:spcPts val="3422"/>
+                <a:spcPts val="3906"/>
               </a:lnSpc>
               <a:spcAft>
-                <a:spcPts val="1400"/>
+                <a:spcPts val="2000"/>
               </a:spcAft>
               <a:buNone/>
             </a:pPr>
             <a:r>
-              <a:rPr lang="en-US" altLang="en-US" sz="2900" dirty="0">
+              <a:rPr lang="en-US" altLang="en-US" sz="3100" dirty="0">
                 <a:solidFill>
                   <a:srgbClr val="111111"/>
                 </a:solidFill>
-                <a:latin typeface="Arial" pitchFamily="34" charset="0"/>
-                <a:ea typeface="Arial" pitchFamily="34" charset="-122"/>
-                <a:cs typeface="Arial" pitchFamily="34" charset="-120"/>
-              </a:rPr>
-              <a:t>Compare ‘S6 Reading Revision — teacher notes’ with the selected HKDSE English Language Curriculum and Assessment Guide and assessment framework. Focus on reading comprehension and supporting answers with text evidence.</a:t>
-            </a:r>
-            <a:endParaRPr lang="en-US" sz="2900" dirty="0"/>
+                <a:latin typeface="Microsoft JhengHei" pitchFamily="34" charset="0"/>
+                <a:ea typeface="Microsoft JhengHei" pitchFamily="34" charset="-122"/>
+                <a:cs typeface="Microsoft JhengHei" pitchFamily="34" charset="-120"/>
+              </a:rPr>
+              <a:t>請把「S6 Reading Revision — teacher notes」與所選HKDSE英文科《課程及評估指引》及評核大綱比較，集中於閱讀理解及以文本證據支持答案。</a:t>
+            </a:r>
+            <a:endParaRPr lang="en-US" sz="3100" dirty="0"/>
           </a:p>
           <a:p>
             <a:pPr algn="l" indent="0" marL="0">
               <a:lnSpc>
-                <a:spcPts val="3422"/>
+                <a:spcPts val="3906"/>
               </a:lnSpc>
               <a:spcAft>
-                <a:spcPts val="1400"/>
+                <a:spcPts val="2000"/>
               </a:spcAft>
               <a:buNone/>
             </a:pPr>
             <a:r>
-              <a:rPr lang="en-US" altLang="en-US" sz="2900" dirty="0">
+              <a:rPr lang="en-US" altLang="en-US" sz="3100" dirty="0">
                 <a:solidFill>
                   <a:srgbClr val="111111"/>
                 </a:solidFill>
-                <a:latin typeface="Arial" pitchFamily="34" charset="0"/>
-                <a:ea typeface="Arial" pitchFamily="34" charset="-122"/>
-                <a:cs typeface="Arial" pitchFamily="34" charset="-120"/>
-              </a:rPr>
-              <a:t>Use a </a:t>
-            </a:r>
-            <a:r>
-              <a:rPr lang="en-US" altLang="en-US" sz="2900" b="1" dirty="0">
+                <a:latin typeface="Microsoft JhengHei" pitchFamily="34" charset="0"/>
+                <a:ea typeface="Microsoft JhengHei" pitchFamily="34" charset="-122"/>
+                <a:cs typeface="Microsoft JhengHei" pitchFamily="34" charset="-120"/>
+              </a:rPr>
+              <a:t>用</a:t>
+            </a:r>
+            <a:r>
+              <a:rPr lang="en-US" altLang="en-US" sz="3100" b="1" dirty="0">
                 <a:solidFill>
                   <a:srgbClr val="111111"/>
                 </a:solidFill>
-                <a:latin typeface="Arial" pitchFamily="34" charset="0"/>
-                <a:ea typeface="Arial" pitchFamily="34" charset="-122"/>
-                <a:cs typeface="Arial" pitchFamily="34" charset="-120"/>
-              </a:rPr>
-              <a:t>four-column table</a:t>
-            </a:r>
-            <a:r>
-              <a:rPr lang="en-US" altLang="en-US" sz="2900" dirty="0">
+                <a:latin typeface="Microsoft JhengHei" pitchFamily="34" charset="0"/>
+                <a:ea typeface="Microsoft JhengHei" pitchFamily="34" charset="-122"/>
+                <a:cs typeface="Microsoft JhengHei" pitchFamily="34" charset="-120"/>
+              </a:rPr>
+              <a:t>四欄表格</a:t>
+            </a:r>
+            <a:r>
+              <a:rPr lang="en-US" altLang="en-US" sz="3100" dirty="0">
                 <a:solidFill>
                   <a:srgbClr val="111111"/>
                 </a:solidFill>
-                <a:latin typeface="Arial" pitchFamily="34" charset="0"/>
-                <a:ea typeface="Arial" pitchFamily="34" charset="-122"/>
-                <a:cs typeface="Arial" pitchFamily="34" charset="-120"/>
-              </a:rPr>
-              <a:t>: Official objective; Evidence in our notes; Coverage (clear / partial / not found); Suggested improvement. Cite both the guidance and our notes. End with three revision-teaching priorities.</a:t>
-            </a:r>
-            <a:endParaRPr lang="en-US" sz="2900" dirty="0"/>
+                <a:latin typeface="Microsoft JhengHei" pitchFamily="34" charset="0"/>
+                <a:ea typeface="Microsoft JhengHei" pitchFamily="34" charset="-122"/>
+                <a:cs typeface="Microsoft JhengHei" pitchFamily="34" charset="-120"/>
+              </a:rPr>
+              <a:t>：官方目標；教材證據；涵蓋程度（清楚／部分／未找到）；改進建議。引用官方資料及筆記，最後列出三項溫習教學重點。</a:t>
+            </a:r>
+            <a:endParaRPr lang="en-US" sz="3100" dirty="0"/>
           </a:p>
           <a:p>
             <a:pPr algn="l" indent="0" marL="0">
               <a:lnSpc>
-                <a:spcPts val="3422"/>
+                <a:spcPts val="3906"/>
               </a:lnSpc>
               <a:spcAft>
-                <a:spcPts val="1400"/>
+                <a:spcPts val="2000"/>
               </a:spcAft>
               <a:buNone/>
             </a:pPr>
             <a:r>
-              <a:rPr lang="en-US" altLang="en-US" sz="2900" dirty="0">
+              <a:rPr lang="en-US" altLang="en-US" sz="3100" dirty="0">
                 <a:solidFill>
                   <a:srgbClr val="111111"/>
                 </a:solidFill>
-                <a:latin typeface="Arial" pitchFamily="34" charset="0"/>
-                <a:ea typeface="Arial" pitchFamily="34" charset="-122"/>
-                <a:cs typeface="Arial" pitchFamily="34" charset="-120"/>
-              </a:rPr>
-              <a:t>Keep curriculum objectives separate from exam rules. Flag anything not stated in the sources. ‘Not found’ refers only to the selected notes.</a:t>
-            </a:r>
-            <a:endParaRPr lang="en-US" sz="2900" dirty="0"/>
+                <a:latin typeface="Microsoft JhengHei" pitchFamily="34" charset="0"/>
+                <a:ea typeface="Microsoft JhengHei" pitchFamily="34" charset="-122"/>
+                <a:cs typeface="Microsoft JhengHei" pitchFamily="34" charset="-120"/>
+              </a:rPr>
+              <a:t>區分課程目標與考試規則。資料未有說明的內容，請指出。「未找到」只指所選筆記。</a:t>
+            </a:r>
+            <a:endParaRPr lang="en-US" sz="3100" dirty="0"/>
           </a:p>
           <a:p>
             <a:pPr algn="l" indent="0" marL="0">
               <a:lnSpc>
-                <a:spcPts val="3422"/>
+                <a:spcPts val="3906"/>
               </a:lnSpc>
               <a:buNone/>
             </a:pPr>
             <a:r>
-              <a:rPr lang="en-US" altLang="en-US" sz="2900" b="1" dirty="0">
+              <a:rPr lang="en-US" altLang="en-US" sz="3100" b="1" dirty="0">
                 <a:solidFill>
                   <a:srgbClr val="E74627"/>
                 </a:solidFill>
-                <a:latin typeface="Arial" pitchFamily="34" charset="0"/>
-                <a:ea typeface="Arial" pitchFamily="34" charset="-122"/>
-                <a:cs typeface="Arial" pitchFamily="34" charset="-120"/>
-              </a:rPr>
-              <a:t>Write in English.</a:t>
-            </a:r>
-            <a:endParaRPr lang="en-US" sz="2900" dirty="0"/>
-          </a:p>
-        </p:txBody>
-      </p:sp>
-      <p:sp>
-        <p:nvSpPr>
-          <p:cNvPr id="6" name="example_english-shape-5"/>
+                <a:latin typeface="Microsoft JhengHei" pitchFamily="34" charset="0"/>
+                <a:ea typeface="Microsoft JhengHei" pitchFamily="34" charset="-122"/>
+                <a:cs typeface="Microsoft JhengHei" pitchFamily="34" charset="-120"/>
+              </a:rPr>
+              <a:t>請以繁體中文回答。</a:t>
+            </a:r>
+            <a:endParaRPr lang="en-US" sz="3100" dirty="0"/>
+          </a:p>
+        </p:txBody>
+      </p:sp>
+      <p:sp>
+        <p:nvSpPr>
+          <p:cNvPr id="6" name="example_chinese-shape-5"/>
           <p:cNvSpPr/>
           <p:nvPr/>
         </p:nvSpPr>
@@ -8347,7 +7483,7 @@
       </p:sp>
       <p:sp>
         <p:nvSpPr>
-          <p:cNvPr id="7" name="example_english-shape-6"/>
+          <p:cNvPr id="7" name="example_chinese-shape-6"/>
           <p:cNvSpPr/>
           <p:nvPr/>
         </p:nvSpPr>
@@ -8371,7 +7507,7 @@
       </p:sp>
       <p:pic>
         <p:nvPicPr>
-          <p:cNvPr id="8" name="example_english-image-7" descr="preencoded.png">    </p:cNvPr>
+          <p:cNvPr id="8" name="example_chinese-image-7" descr="preencoded.png">    </p:cNvPr>
           <p:cNvPicPr>
             <a:picLocks noChangeAspect="1"/>
           </p:cNvPicPr>
@@ -8394,7 +7530,7 @@
       </p:pic>
       <p:sp>
         <p:nvSpPr>
-          <p:cNvPr id="9" name="example_english-text-8"/>
+          <p:cNvPr id="9" name="example_chinese-text-8"/>
           <p:cNvSpPr/>
           <p:nvPr/>
         </p:nvSpPr>
@@ -8433,7 +7569,7 @@
       </p:sp>
       <p:sp>
         <p:nvSpPr>
-          <p:cNvPr id="10" name="example_english-text-9"/>
+          <p:cNvPr id="10" name="example_chinese-text-9"/>
           <p:cNvSpPr/>
           <p:nvPr/>
         </p:nvSpPr>
@@ -8472,7 +7608,7 @@
       </p:sp>
       <p:sp>
         <p:nvSpPr>
-          <p:cNvPr id="11" name="example_english-text-10"/>
+          <p:cNvPr id="11" name="example_chinese-text-10"/>
           <p:cNvSpPr/>
           <p:nvPr/>
         </p:nvSpPr>
@@ -8566,30 +7702,30 @@
       </p:pic>
       <p:sp>
         <p:nvSpPr>
-          <p:cNvPr id="3" name="example_chinese-text-2"/>
+          <p:cNvPr id="3" name="prompt_menu-text-2"/>
           <p:cNvSpPr/>
           <p:nvPr/>
         </p:nvSpPr>
         <p:spPr>
           <a:xfrm>
             <a:off x="762000" y="952500"/>
-            <a:ext cx="14732000" cy="889000"/>
-          </a:xfrm>
-          <a:prstGeom prst="rect">
-            <a:avLst/>
-          </a:prstGeom>
-          <a:noFill/>
-          <a:ln/>
-        </p:spPr>
-        <p:txBody>
-          <a:bodyPr wrap="square" lIns="0" tIns="0" rIns="0" bIns="0" rtlCol="0" anchor="t"/>
-          <a:lstStyle/>
-          <a:p>
-            <a:pPr algn="l" indent="0" marL="0">
-              <a:buNone/>
-            </a:pPr>
-            <a:r>
-              <a:rPr lang="en-US" altLang="en-US" sz="4800" b="1" dirty="0">
+            <a:ext cx="14732000" cy="1003300"/>
+          </a:xfrm>
+          <a:prstGeom prst="rect">
+            <a:avLst/>
+          </a:prstGeom>
+          <a:noFill/>
+          <a:ln/>
+        </p:spPr>
+        <p:txBody>
+          <a:bodyPr wrap="square" lIns="0" tIns="0" rIns="0" bIns="0" rtlCol="0" anchor="t"/>
+          <a:lstStyle/>
+          <a:p>
+            <a:pPr algn="l" indent="0" marL="0">
+              <a:buNone/>
+            </a:pPr>
+            <a:r>
+              <a:rPr lang="en-US" altLang="en-US" sz="5400" b="1" dirty="0">
                 <a:solidFill>
                   <a:srgbClr val="111111"/>
                 </a:solidFill>
@@ -8597,32 +7733,21 @@
                 <a:ea typeface="Arial" pitchFamily="34" charset="-122"/>
                 <a:cs typeface="Arial" pitchFamily="34" charset="-120"/>
               </a:rPr>
-              <a:t>Example 1 </a:t>
-            </a:r>
-            <a:r>
-              <a:rPr lang="en-US" altLang="en-US" sz="4800" b="1" dirty="0">
-                <a:solidFill>
-                  <a:srgbClr val="E74627"/>
-                </a:solidFill>
-                <a:latin typeface="Microsoft JhengHei" pitchFamily="34" charset="0"/>
-                <a:ea typeface="Microsoft JhengHei" pitchFamily="34" charset="-122"/>
-                <a:cs typeface="Microsoft JhengHei" pitchFamily="34" charset="-120"/>
-              </a:rPr>
-              <a:t>/ 繁體中文提示詞</a:t>
-            </a:r>
-            <a:endParaRPr lang="en-US" sz="4800" dirty="0"/>
-          </a:p>
-        </p:txBody>
-      </p:sp>
-      <p:sp>
-        <p:nvSpPr>
-          <p:cNvPr id="4" name="example_chinese-shape-3"/>
-          <p:cNvSpPr/>
-          <p:nvPr/>
-        </p:nvSpPr>
-        <p:spPr>
-          <a:xfrm>
-            <a:off x="762000" y="2082800"/>
+              <a:t>Ten useful prompts for teachers.</a:t>
+            </a:r>
+            <a:endParaRPr lang="en-US" sz="5400" dirty="0"/>
+          </a:p>
+        </p:txBody>
+      </p:sp>
+      <p:sp>
+        <p:nvSpPr>
+          <p:cNvPr id="4" name="prompt_menu-shape-3"/>
+          <p:cNvSpPr/>
+          <p:nvPr/>
+        </p:nvSpPr>
+        <p:spPr>
+          <a:xfrm>
+            <a:off x="762000" y="2247900"/>
             <a:ext cx="14732000" cy="9144"/>
           </a:xfrm>
           <a:prstGeom prst="line">
@@ -8638,147 +7763,14 @@
       </p:sp>
       <p:sp>
         <p:nvSpPr>
-          <p:cNvPr id="5" name="example_chinese-text-4"/>
-          <p:cNvSpPr/>
-          <p:nvPr/>
-        </p:nvSpPr>
-        <p:spPr>
-          <a:xfrm>
-            <a:off x="762000" y="2451100"/>
-            <a:ext cx="14732000" cy="5384800"/>
-          </a:xfrm>
-          <a:prstGeom prst="rect">
-            <a:avLst/>
-          </a:prstGeom>
-          <a:noFill/>
-          <a:ln/>
-        </p:spPr>
-        <p:txBody>
-          <a:bodyPr wrap="square" lIns="0" tIns="0" rIns="0" bIns="0" rtlCol="0" anchor="t"/>
-          <a:lstStyle/>
-          <a:p>
-            <a:pPr algn="l" indent="0" marL="0">
-              <a:lnSpc>
-                <a:spcPts val="3906"/>
-              </a:lnSpc>
-              <a:spcAft>
-                <a:spcPts val="2000"/>
-              </a:spcAft>
-              <a:buNone/>
-            </a:pPr>
-            <a:r>
-              <a:rPr lang="en-US" altLang="en-US" sz="3100" dirty="0">
-                <a:solidFill>
-                  <a:srgbClr val="111111"/>
-                </a:solidFill>
-                <a:latin typeface="Microsoft JhengHei" pitchFamily="34" charset="0"/>
-                <a:ea typeface="Microsoft JhengHei" pitchFamily="34" charset="-122"/>
-                <a:cs typeface="Microsoft JhengHei" pitchFamily="34" charset="-120"/>
-              </a:rPr>
-              <a:t>請把「S6 Reading Revision — teacher notes」與所選HKDSE英文科《課程及評估指引》及評核大綱比較，集中於閱讀理解及以文本證據支持答案。</a:t>
-            </a:r>
-            <a:endParaRPr lang="en-US" sz="3100" dirty="0"/>
-          </a:p>
-          <a:p>
-            <a:pPr algn="l" indent="0" marL="0">
-              <a:lnSpc>
-                <a:spcPts val="3906"/>
-              </a:lnSpc>
-              <a:spcAft>
-                <a:spcPts val="2000"/>
-              </a:spcAft>
-              <a:buNone/>
-            </a:pPr>
-            <a:r>
-              <a:rPr lang="en-US" altLang="en-US" sz="3100" dirty="0">
-                <a:solidFill>
-                  <a:srgbClr val="111111"/>
-                </a:solidFill>
-                <a:latin typeface="Microsoft JhengHei" pitchFamily="34" charset="0"/>
-                <a:ea typeface="Microsoft JhengHei" pitchFamily="34" charset="-122"/>
-                <a:cs typeface="Microsoft JhengHei" pitchFamily="34" charset="-120"/>
-              </a:rPr>
-              <a:t>用</a:t>
-            </a:r>
-            <a:r>
-              <a:rPr lang="en-US" altLang="en-US" sz="3100" b="1" dirty="0">
-                <a:solidFill>
-                  <a:srgbClr val="111111"/>
-                </a:solidFill>
-                <a:latin typeface="Microsoft JhengHei" pitchFamily="34" charset="0"/>
-                <a:ea typeface="Microsoft JhengHei" pitchFamily="34" charset="-122"/>
-                <a:cs typeface="Microsoft JhengHei" pitchFamily="34" charset="-120"/>
-              </a:rPr>
-              <a:t>四欄表格</a:t>
-            </a:r>
-            <a:r>
-              <a:rPr lang="en-US" altLang="en-US" sz="3100" dirty="0">
-                <a:solidFill>
-                  <a:srgbClr val="111111"/>
-                </a:solidFill>
-                <a:latin typeface="Microsoft JhengHei" pitchFamily="34" charset="0"/>
-                <a:ea typeface="Microsoft JhengHei" pitchFamily="34" charset="-122"/>
-                <a:cs typeface="Microsoft JhengHei" pitchFamily="34" charset="-120"/>
-              </a:rPr>
-              <a:t>：官方目標；教材證據；涵蓋程度（清楚／部分／未找到）；改進建議。引用官方資料及筆記，最後列出三項溫習教學重點。</a:t>
-            </a:r>
-            <a:endParaRPr lang="en-US" sz="3100" dirty="0"/>
-          </a:p>
-          <a:p>
-            <a:pPr algn="l" indent="0" marL="0">
-              <a:lnSpc>
-                <a:spcPts val="3906"/>
-              </a:lnSpc>
-              <a:spcAft>
-                <a:spcPts val="2000"/>
-              </a:spcAft>
-              <a:buNone/>
-            </a:pPr>
-            <a:r>
-              <a:rPr lang="en-US" altLang="en-US" sz="3100" dirty="0">
-                <a:solidFill>
-                  <a:srgbClr val="111111"/>
-                </a:solidFill>
-                <a:latin typeface="Microsoft JhengHei" pitchFamily="34" charset="0"/>
-                <a:ea typeface="Microsoft JhengHei" pitchFamily="34" charset="-122"/>
-                <a:cs typeface="Microsoft JhengHei" pitchFamily="34" charset="-120"/>
-              </a:rPr>
-              <a:t>區分課程目標與考試規則。資料未有說明的內容，請指出。「未找到」只指所選筆記。</a:t>
-            </a:r>
-            <a:endParaRPr lang="en-US" sz="3100" dirty="0"/>
-          </a:p>
-          <a:p>
-            <a:pPr algn="l" indent="0" marL="0">
-              <a:lnSpc>
-                <a:spcPts val="3906"/>
-              </a:lnSpc>
-              <a:buNone/>
-            </a:pPr>
-            <a:r>
-              <a:rPr lang="en-US" altLang="en-US" sz="3100" b="1" dirty="0">
-                <a:solidFill>
-                  <a:srgbClr val="E74627"/>
-                </a:solidFill>
-                <a:latin typeface="Microsoft JhengHei" pitchFamily="34" charset="0"/>
-                <a:ea typeface="Microsoft JhengHei" pitchFamily="34" charset="-122"/>
-                <a:cs typeface="Microsoft JhengHei" pitchFamily="34" charset="-120"/>
-              </a:rPr>
-              <a:t>請以繁體中文回答。</a:t>
-            </a:r>
-            <a:endParaRPr lang="en-US" sz="3100" dirty="0"/>
-          </a:p>
-        </p:txBody>
-      </p:sp>
-      <p:sp>
-        <p:nvSpPr>
-          <p:cNvPr id="6" name="example_chinese-shape-5"/>
-          <p:cNvSpPr/>
-          <p:nvPr/>
-        </p:nvSpPr>
-        <p:spPr>
-          <a:xfrm>
-            <a:off x="762000" y="8102600"/>
-            <a:ext cx="14732000" cy="9144"/>
+          <p:cNvPr id="5" name="prompt_menu-shape-4"/>
+          <p:cNvSpPr/>
+          <p:nvPr/>
+        </p:nvSpPr>
+        <p:spPr>
+          <a:xfrm>
+            <a:off x="8140700" y="2717800"/>
+            <a:ext cx="9144" cy="4813300"/>
           </a:xfrm>
           <a:prstGeom prst="line">
             <a:avLst/>
@@ -8793,7 +7785,1015 @@
       </p:sp>
       <p:sp>
         <p:nvSpPr>
-          <p:cNvPr id="7" name="example_chinese-shape-6"/>
+          <p:cNvPr id="6" name="prompt_menu-text-5"/>
+          <p:cNvSpPr/>
+          <p:nvPr/>
+        </p:nvSpPr>
+        <p:spPr>
+          <a:xfrm>
+            <a:off x="762000" y="2743200"/>
+            <a:ext cx="762000" cy="558800"/>
+          </a:xfrm>
+          <a:prstGeom prst="rect">
+            <a:avLst/>
+          </a:prstGeom>
+          <a:noFill/>
+          <a:ln/>
+        </p:spPr>
+        <p:txBody>
+          <a:bodyPr wrap="square" lIns="0" tIns="0" rIns="0" bIns="0" rtlCol="0" anchor="t"/>
+          <a:lstStyle/>
+          <a:p>
+            <a:pPr algn="l" indent="0" marL="0">
+              <a:buNone/>
+            </a:pPr>
+            <a:r>
+              <a:rPr lang="en-US" altLang="en-US" sz="3100" b="1" dirty="0">
+                <a:solidFill>
+                  <a:srgbClr val="E74627"/>
+                </a:solidFill>
+                <a:latin typeface="Arial" pitchFamily="34" charset="0"/>
+                <a:ea typeface="Arial" pitchFamily="34" charset="-122"/>
+                <a:cs typeface="Arial" pitchFamily="34" charset="-120"/>
+              </a:rPr>
+              <a:t>01</a:t>
+            </a:r>
+            <a:endParaRPr lang="en-US" sz="3100" dirty="0"/>
+          </a:p>
+        </p:txBody>
+      </p:sp>
+      <p:sp>
+        <p:nvSpPr>
+          <p:cNvPr id="7" name="prompt_menu-text-6"/>
+          <p:cNvSpPr/>
+          <p:nvPr/>
+        </p:nvSpPr>
+        <p:spPr>
+          <a:xfrm>
+            <a:off x="1536700" y="2717800"/>
+            <a:ext cx="6248400" cy="812800"/>
+          </a:xfrm>
+          <a:prstGeom prst="rect">
+            <a:avLst/>
+          </a:prstGeom>
+          <a:noFill/>
+          <a:ln/>
+        </p:spPr>
+        <p:txBody>
+          <a:bodyPr wrap="square" lIns="0" tIns="0" rIns="0" bIns="0" rtlCol="0" anchor="t"/>
+          <a:lstStyle/>
+          <a:p>
+            <a:pPr algn="l" indent="0" marL="0">
+              <a:lnSpc>
+                <a:spcPts val="2990"/>
+              </a:lnSpc>
+              <a:buNone/>
+            </a:pPr>
+            <a:r>
+              <a:rPr lang="en-US" altLang="en-US" sz="2600" dirty="0">
+                <a:solidFill>
+                  <a:srgbClr val="111111"/>
+                </a:solidFill>
+                <a:latin typeface="Arial" pitchFamily="34" charset="0"/>
+                <a:ea typeface="Arial" pitchFamily="34" charset="-122"/>
+                <a:cs typeface="Arial" pitchFamily="34" charset="-120"/>
+              </a:rPr>
+              <a:t>Check materials against HKDSE requirements</a:t>
+            </a:r>
+            <a:endParaRPr lang="en-US" sz="2600" dirty="0"/>
+          </a:p>
+        </p:txBody>
+      </p:sp>
+      <p:sp>
+        <p:nvSpPr>
+          <p:cNvPr id="8" name="prompt_menu-shape-7"/>
+          <p:cNvSpPr/>
+          <p:nvPr/>
+        </p:nvSpPr>
+        <p:spPr>
+          <a:xfrm>
+            <a:off x="762000" y="3606800"/>
+            <a:ext cx="6985000" cy="9144"/>
+          </a:xfrm>
+          <a:prstGeom prst="line">
+            <a:avLst/>
+          </a:prstGeom>
+          <a:ln w="12700">
+            <a:solidFill>
+              <a:srgbClr val="CCCCC5"/>
+            </a:solidFill>
+            <a:prstDash val="solid"/>
+          </a:ln>
+        </p:spPr>
+      </p:sp>
+      <p:sp>
+        <p:nvSpPr>
+          <p:cNvPr id="9" name="prompt_menu-text-8"/>
+          <p:cNvSpPr/>
+          <p:nvPr/>
+        </p:nvSpPr>
+        <p:spPr>
+          <a:xfrm>
+            <a:off x="762000" y="3759200"/>
+            <a:ext cx="762000" cy="558800"/>
+          </a:xfrm>
+          <a:prstGeom prst="rect">
+            <a:avLst/>
+          </a:prstGeom>
+          <a:noFill/>
+          <a:ln/>
+        </p:spPr>
+        <p:txBody>
+          <a:bodyPr wrap="square" lIns="0" tIns="0" rIns="0" bIns="0" rtlCol="0" anchor="t"/>
+          <a:lstStyle/>
+          <a:p>
+            <a:pPr algn="l" indent="0" marL="0">
+              <a:buNone/>
+            </a:pPr>
+            <a:r>
+              <a:rPr lang="en-US" altLang="en-US" sz="3100" b="1" dirty="0">
+                <a:solidFill>
+                  <a:srgbClr val="E74627"/>
+                </a:solidFill>
+                <a:latin typeface="Arial" pitchFamily="34" charset="0"/>
+                <a:ea typeface="Arial" pitchFamily="34" charset="-122"/>
+                <a:cs typeface="Arial" pitchFamily="34" charset="-120"/>
+              </a:rPr>
+              <a:t>02</a:t>
+            </a:r>
+            <a:endParaRPr lang="en-US" sz="3100" dirty="0"/>
+          </a:p>
+        </p:txBody>
+      </p:sp>
+      <p:sp>
+        <p:nvSpPr>
+          <p:cNvPr id="10" name="prompt_menu-text-9"/>
+          <p:cNvSpPr/>
+          <p:nvPr/>
+        </p:nvSpPr>
+        <p:spPr>
+          <a:xfrm>
+            <a:off x="1536700" y="3733800"/>
+            <a:ext cx="6248400" cy="812800"/>
+          </a:xfrm>
+          <a:prstGeom prst="rect">
+            <a:avLst/>
+          </a:prstGeom>
+          <a:noFill/>
+          <a:ln/>
+        </p:spPr>
+        <p:txBody>
+          <a:bodyPr wrap="square" lIns="0" tIns="0" rIns="0" bIns="0" rtlCol="0" anchor="t"/>
+          <a:lstStyle/>
+          <a:p>
+            <a:pPr algn="l" indent="0" marL="0">
+              <a:lnSpc>
+                <a:spcPts val="2990"/>
+              </a:lnSpc>
+              <a:buNone/>
+            </a:pPr>
+            <a:r>
+              <a:rPr lang="en-US" altLang="en-US" sz="2600" dirty="0">
+                <a:solidFill>
+                  <a:srgbClr val="111111"/>
+                </a:solidFill>
+                <a:latin typeface="Arial" pitchFamily="34" charset="0"/>
+                <a:ea typeface="Arial" pitchFamily="34" charset="-122"/>
+                <a:cs typeface="Arial" pitchFamily="34" charset="-120"/>
+              </a:rPr>
+              <a:t>Turn an HKEAA briefing into revision-teaching notes</a:t>
+            </a:r>
+            <a:endParaRPr lang="en-US" sz="2600" dirty="0"/>
+          </a:p>
+        </p:txBody>
+      </p:sp>
+      <p:sp>
+        <p:nvSpPr>
+          <p:cNvPr id="11" name="prompt_menu-shape-10"/>
+          <p:cNvSpPr/>
+          <p:nvPr/>
+        </p:nvSpPr>
+        <p:spPr>
+          <a:xfrm>
+            <a:off x="762000" y="4622800"/>
+            <a:ext cx="6985000" cy="9144"/>
+          </a:xfrm>
+          <a:prstGeom prst="line">
+            <a:avLst/>
+          </a:prstGeom>
+          <a:ln w="12700">
+            <a:solidFill>
+              <a:srgbClr val="CCCCC5"/>
+            </a:solidFill>
+            <a:prstDash val="solid"/>
+          </a:ln>
+        </p:spPr>
+      </p:sp>
+      <p:sp>
+        <p:nvSpPr>
+          <p:cNvPr id="12" name="prompt_menu-text-11"/>
+          <p:cNvSpPr/>
+          <p:nvPr/>
+        </p:nvSpPr>
+        <p:spPr>
+          <a:xfrm>
+            <a:off x="762000" y="4775200"/>
+            <a:ext cx="762000" cy="558800"/>
+          </a:xfrm>
+          <a:prstGeom prst="rect">
+            <a:avLst/>
+          </a:prstGeom>
+          <a:noFill/>
+          <a:ln/>
+        </p:spPr>
+        <p:txBody>
+          <a:bodyPr wrap="square" lIns="0" tIns="0" rIns="0" bIns="0" rtlCol="0" anchor="t"/>
+          <a:lstStyle/>
+          <a:p>
+            <a:pPr algn="l" indent="0" marL="0">
+              <a:buNone/>
+            </a:pPr>
+            <a:r>
+              <a:rPr lang="en-US" altLang="en-US" sz="3100" b="1" dirty="0">
+                <a:solidFill>
+                  <a:srgbClr val="E74627"/>
+                </a:solidFill>
+                <a:latin typeface="Arial" pitchFamily="34" charset="0"/>
+                <a:ea typeface="Arial" pitchFamily="34" charset="-122"/>
+                <a:cs typeface="Arial" pitchFamily="34" charset="-120"/>
+              </a:rPr>
+              <a:t>03</a:t>
+            </a:r>
+            <a:endParaRPr lang="en-US" sz="3100" dirty="0"/>
+          </a:p>
+        </p:txBody>
+      </p:sp>
+      <p:sp>
+        <p:nvSpPr>
+          <p:cNvPr id="13" name="prompt_menu-text-12"/>
+          <p:cNvSpPr/>
+          <p:nvPr/>
+        </p:nvSpPr>
+        <p:spPr>
+          <a:xfrm>
+            <a:off x="1536700" y="4749800"/>
+            <a:ext cx="6248400" cy="812800"/>
+          </a:xfrm>
+          <a:prstGeom prst="rect">
+            <a:avLst/>
+          </a:prstGeom>
+          <a:noFill/>
+          <a:ln/>
+        </p:spPr>
+        <p:txBody>
+          <a:bodyPr wrap="square" lIns="0" tIns="0" rIns="0" bIns="0" rtlCol="0" anchor="t"/>
+          <a:lstStyle/>
+          <a:p>
+            <a:pPr algn="l" indent="0" marL="0">
+              <a:lnSpc>
+                <a:spcPts val="2990"/>
+              </a:lnSpc>
+              <a:buNone/>
+            </a:pPr>
+            <a:r>
+              <a:rPr lang="en-US" altLang="en-US" sz="2600" dirty="0">
+                <a:solidFill>
+                  <a:srgbClr val="111111"/>
+                </a:solidFill>
+                <a:latin typeface="Arial" pitchFamily="34" charset="0"/>
+                <a:ea typeface="Arial" pitchFamily="34" charset="-122"/>
+                <a:cs typeface="Arial" pitchFamily="34" charset="-120"/>
+              </a:rPr>
+              <a:t>Plan an HKDSE lesson with an exit ticket</a:t>
+            </a:r>
+            <a:endParaRPr lang="en-US" sz="2600" dirty="0"/>
+          </a:p>
+        </p:txBody>
+      </p:sp>
+      <p:sp>
+        <p:nvSpPr>
+          <p:cNvPr id="14" name="prompt_menu-shape-13"/>
+          <p:cNvSpPr/>
+          <p:nvPr/>
+        </p:nvSpPr>
+        <p:spPr>
+          <a:xfrm>
+            <a:off x="762000" y="5638800"/>
+            <a:ext cx="6985000" cy="9144"/>
+          </a:xfrm>
+          <a:prstGeom prst="line">
+            <a:avLst/>
+          </a:prstGeom>
+          <a:ln w="12700">
+            <a:solidFill>
+              <a:srgbClr val="CCCCC5"/>
+            </a:solidFill>
+            <a:prstDash val="solid"/>
+          </a:ln>
+        </p:spPr>
+      </p:sp>
+      <p:sp>
+        <p:nvSpPr>
+          <p:cNvPr id="15" name="prompt_menu-text-14"/>
+          <p:cNvSpPr/>
+          <p:nvPr/>
+        </p:nvSpPr>
+        <p:spPr>
+          <a:xfrm>
+            <a:off x="762000" y="5791200"/>
+            <a:ext cx="762000" cy="558800"/>
+          </a:xfrm>
+          <a:prstGeom prst="rect">
+            <a:avLst/>
+          </a:prstGeom>
+          <a:noFill/>
+          <a:ln/>
+        </p:spPr>
+        <p:txBody>
+          <a:bodyPr wrap="square" lIns="0" tIns="0" rIns="0" bIns="0" rtlCol="0" anchor="t"/>
+          <a:lstStyle/>
+          <a:p>
+            <a:pPr algn="l" indent="0" marL="0">
+              <a:buNone/>
+            </a:pPr>
+            <a:r>
+              <a:rPr lang="en-US" altLang="en-US" sz="3100" b="1" dirty="0">
+                <a:solidFill>
+                  <a:srgbClr val="E74627"/>
+                </a:solidFill>
+                <a:latin typeface="Arial" pitchFamily="34" charset="0"/>
+                <a:ea typeface="Arial" pitchFamily="34" charset="-122"/>
+                <a:cs typeface="Arial" pitchFamily="34" charset="-120"/>
+              </a:rPr>
+              <a:t>04</a:t>
+            </a:r>
+            <a:endParaRPr lang="en-US" sz="3100" dirty="0"/>
+          </a:p>
+        </p:txBody>
+      </p:sp>
+      <p:sp>
+        <p:nvSpPr>
+          <p:cNvPr id="16" name="prompt_menu-text-15"/>
+          <p:cNvSpPr/>
+          <p:nvPr/>
+        </p:nvSpPr>
+        <p:spPr>
+          <a:xfrm>
+            <a:off x="1536700" y="5765800"/>
+            <a:ext cx="6248400" cy="812800"/>
+          </a:xfrm>
+          <a:prstGeom prst="rect">
+            <a:avLst/>
+          </a:prstGeom>
+          <a:noFill/>
+          <a:ln/>
+        </p:spPr>
+        <p:txBody>
+          <a:bodyPr wrap="square" lIns="0" tIns="0" rIns="0" bIns="0" rtlCol="0" anchor="t"/>
+          <a:lstStyle/>
+          <a:p>
+            <a:pPr algn="l" indent="0" marL="0">
+              <a:lnSpc>
+                <a:spcPts val="2990"/>
+              </a:lnSpc>
+              <a:buNone/>
+            </a:pPr>
+            <a:r>
+              <a:rPr lang="en-US" altLang="en-US" sz="2600" dirty="0">
+                <a:solidFill>
+                  <a:srgbClr val="111111"/>
+                </a:solidFill>
+                <a:latin typeface="Arial" pitchFamily="34" charset="0"/>
+                <a:ea typeface="Arial" pitchFamily="34" charset="-122"/>
+                <a:cs typeface="Arial" pitchFamily="34" charset="-120"/>
+              </a:rPr>
+              <a:t>Support different levels—keep the same learning goal</a:t>
+            </a:r>
+            <a:endParaRPr lang="en-US" sz="2600" dirty="0"/>
+          </a:p>
+        </p:txBody>
+      </p:sp>
+      <p:sp>
+        <p:nvSpPr>
+          <p:cNvPr id="17" name="prompt_menu-shape-16"/>
+          <p:cNvSpPr/>
+          <p:nvPr/>
+        </p:nvSpPr>
+        <p:spPr>
+          <a:xfrm>
+            <a:off x="762000" y="6654800"/>
+            <a:ext cx="6985000" cy="9144"/>
+          </a:xfrm>
+          <a:prstGeom prst="line">
+            <a:avLst/>
+          </a:prstGeom>
+          <a:ln w="12700">
+            <a:solidFill>
+              <a:srgbClr val="CCCCC5"/>
+            </a:solidFill>
+            <a:prstDash val="solid"/>
+          </a:ln>
+        </p:spPr>
+      </p:sp>
+      <p:sp>
+        <p:nvSpPr>
+          <p:cNvPr id="18" name="prompt_menu-text-17"/>
+          <p:cNvSpPr/>
+          <p:nvPr/>
+        </p:nvSpPr>
+        <p:spPr>
+          <a:xfrm>
+            <a:off x="762000" y="6807200"/>
+            <a:ext cx="762000" cy="558800"/>
+          </a:xfrm>
+          <a:prstGeom prst="rect">
+            <a:avLst/>
+          </a:prstGeom>
+          <a:noFill/>
+          <a:ln/>
+        </p:spPr>
+        <p:txBody>
+          <a:bodyPr wrap="square" lIns="0" tIns="0" rIns="0" bIns="0" rtlCol="0" anchor="t"/>
+          <a:lstStyle/>
+          <a:p>
+            <a:pPr algn="l" indent="0" marL="0">
+              <a:buNone/>
+            </a:pPr>
+            <a:r>
+              <a:rPr lang="en-US" altLang="en-US" sz="3100" b="1" dirty="0">
+                <a:solidFill>
+                  <a:srgbClr val="E74627"/>
+                </a:solidFill>
+                <a:latin typeface="Arial" pitchFamily="34" charset="0"/>
+                <a:ea typeface="Arial" pitchFamily="34" charset="-122"/>
+                <a:cs typeface="Arial" pitchFamily="34" charset="-120"/>
+              </a:rPr>
+              <a:t>05</a:t>
+            </a:r>
+            <a:endParaRPr lang="en-US" sz="3100" dirty="0"/>
+          </a:p>
+        </p:txBody>
+      </p:sp>
+      <p:sp>
+        <p:nvSpPr>
+          <p:cNvPr id="19" name="prompt_menu-text-18"/>
+          <p:cNvSpPr/>
+          <p:nvPr/>
+        </p:nvSpPr>
+        <p:spPr>
+          <a:xfrm>
+            <a:off x="1536700" y="6781800"/>
+            <a:ext cx="6248400" cy="812800"/>
+          </a:xfrm>
+          <a:prstGeom prst="rect">
+            <a:avLst/>
+          </a:prstGeom>
+          <a:noFill/>
+          <a:ln/>
+        </p:spPr>
+        <p:txBody>
+          <a:bodyPr wrap="square" lIns="0" tIns="0" rIns="0" bIns="0" rtlCol="0" anchor="t"/>
+          <a:lstStyle/>
+          <a:p>
+            <a:pPr algn="l" indent="0" marL="0">
+              <a:lnSpc>
+                <a:spcPts val="2990"/>
+              </a:lnSpc>
+              <a:buNone/>
+            </a:pPr>
+            <a:r>
+              <a:rPr lang="en-US" altLang="en-US" sz="2600" dirty="0">
+                <a:solidFill>
+                  <a:srgbClr val="111111"/>
+                </a:solidFill>
+                <a:latin typeface="Arial" pitchFamily="34" charset="0"/>
+                <a:ea typeface="Arial" pitchFamily="34" charset="-122"/>
+                <a:cs typeface="Arial" pitchFamily="34" charset="-120"/>
+              </a:rPr>
+              <a:t>Draft HKDSE-style practice and a separate answer key</a:t>
+            </a:r>
+            <a:endParaRPr lang="en-US" sz="2600" dirty="0"/>
+          </a:p>
+        </p:txBody>
+      </p:sp>
+      <p:sp>
+        <p:nvSpPr>
+          <p:cNvPr id="20" name="prompt_menu-text-19"/>
+          <p:cNvSpPr/>
+          <p:nvPr/>
+        </p:nvSpPr>
+        <p:spPr>
+          <a:xfrm>
+            <a:off x="8585200" y="2743200"/>
+            <a:ext cx="762000" cy="558800"/>
+          </a:xfrm>
+          <a:prstGeom prst="rect">
+            <a:avLst/>
+          </a:prstGeom>
+          <a:noFill/>
+          <a:ln/>
+        </p:spPr>
+        <p:txBody>
+          <a:bodyPr wrap="square" lIns="0" tIns="0" rIns="0" bIns="0" rtlCol="0" anchor="t"/>
+          <a:lstStyle/>
+          <a:p>
+            <a:pPr algn="l" indent="0" marL="0">
+              <a:buNone/>
+            </a:pPr>
+            <a:r>
+              <a:rPr lang="en-US" altLang="en-US" sz="3100" b="1" dirty="0">
+                <a:solidFill>
+                  <a:srgbClr val="E74627"/>
+                </a:solidFill>
+                <a:latin typeface="Arial" pitchFamily="34" charset="0"/>
+                <a:ea typeface="Arial" pitchFamily="34" charset="-122"/>
+                <a:cs typeface="Arial" pitchFamily="34" charset="-120"/>
+              </a:rPr>
+              <a:t>06</a:t>
+            </a:r>
+            <a:endParaRPr lang="en-US" sz="3100" dirty="0"/>
+          </a:p>
+        </p:txBody>
+      </p:sp>
+      <p:sp>
+        <p:nvSpPr>
+          <p:cNvPr id="21" name="prompt_menu-text-20"/>
+          <p:cNvSpPr/>
+          <p:nvPr/>
+        </p:nvSpPr>
+        <p:spPr>
+          <a:xfrm>
+            <a:off x="9359900" y="2717800"/>
+            <a:ext cx="6134100" cy="812800"/>
+          </a:xfrm>
+          <a:prstGeom prst="rect">
+            <a:avLst/>
+          </a:prstGeom>
+          <a:noFill/>
+          <a:ln/>
+        </p:spPr>
+        <p:txBody>
+          <a:bodyPr wrap="square" lIns="0" tIns="0" rIns="0" bIns="0" rtlCol="0" anchor="t"/>
+          <a:lstStyle/>
+          <a:p>
+            <a:pPr algn="l" indent="0" marL="0">
+              <a:lnSpc>
+                <a:spcPts val="2990"/>
+              </a:lnSpc>
+              <a:buNone/>
+            </a:pPr>
+            <a:r>
+              <a:rPr lang="en-US" altLang="en-US" sz="2600" dirty="0">
+                <a:solidFill>
+                  <a:srgbClr val="111111"/>
+                </a:solidFill>
+                <a:latin typeface="Arial" pitchFamily="34" charset="0"/>
+                <a:ea typeface="Arial" pitchFamily="34" charset="-122"/>
+                <a:cs typeface="Arial" pitchFamily="34" charset="-120"/>
+              </a:rPr>
+              <a:t>Turn fictional errors into feedback and reteaching</a:t>
+            </a:r>
+            <a:endParaRPr lang="en-US" sz="2600" dirty="0"/>
+          </a:p>
+        </p:txBody>
+      </p:sp>
+      <p:sp>
+        <p:nvSpPr>
+          <p:cNvPr id="22" name="prompt_menu-shape-21"/>
+          <p:cNvSpPr/>
+          <p:nvPr/>
+        </p:nvSpPr>
+        <p:spPr>
+          <a:xfrm>
+            <a:off x="8585200" y="3606800"/>
+            <a:ext cx="6908800" cy="9144"/>
+          </a:xfrm>
+          <a:prstGeom prst="line">
+            <a:avLst/>
+          </a:prstGeom>
+          <a:ln w="12700">
+            <a:solidFill>
+              <a:srgbClr val="CCCCC5"/>
+            </a:solidFill>
+            <a:prstDash val="solid"/>
+          </a:ln>
+        </p:spPr>
+      </p:sp>
+      <p:sp>
+        <p:nvSpPr>
+          <p:cNvPr id="23" name="prompt_menu-text-22"/>
+          <p:cNvSpPr/>
+          <p:nvPr/>
+        </p:nvSpPr>
+        <p:spPr>
+          <a:xfrm>
+            <a:off x="8585200" y="3759200"/>
+            <a:ext cx="762000" cy="558800"/>
+          </a:xfrm>
+          <a:prstGeom prst="rect">
+            <a:avLst/>
+          </a:prstGeom>
+          <a:noFill/>
+          <a:ln/>
+        </p:spPr>
+        <p:txBody>
+          <a:bodyPr wrap="square" lIns="0" tIns="0" rIns="0" bIns="0" rtlCol="0" anchor="t"/>
+          <a:lstStyle/>
+          <a:p>
+            <a:pPr algn="l" indent="0" marL="0">
+              <a:buNone/>
+            </a:pPr>
+            <a:r>
+              <a:rPr lang="en-US" altLang="en-US" sz="3100" b="1" dirty="0">
+                <a:solidFill>
+                  <a:srgbClr val="E74627"/>
+                </a:solidFill>
+                <a:latin typeface="Arial" pitchFamily="34" charset="0"/>
+                <a:ea typeface="Arial" pitchFamily="34" charset="-122"/>
+                <a:cs typeface="Arial" pitchFamily="34" charset="-120"/>
+              </a:rPr>
+              <a:t>07</a:t>
+            </a:r>
+            <a:endParaRPr lang="en-US" sz="3100" dirty="0"/>
+          </a:p>
+        </p:txBody>
+      </p:sp>
+      <p:sp>
+        <p:nvSpPr>
+          <p:cNvPr id="24" name="prompt_menu-text-23"/>
+          <p:cNvSpPr/>
+          <p:nvPr/>
+        </p:nvSpPr>
+        <p:spPr>
+          <a:xfrm>
+            <a:off x="9359900" y="3733800"/>
+            <a:ext cx="6134100" cy="812800"/>
+          </a:xfrm>
+          <a:prstGeom prst="rect">
+            <a:avLst/>
+          </a:prstGeom>
+          <a:noFill/>
+          <a:ln/>
+        </p:spPr>
+        <p:txBody>
+          <a:bodyPr wrap="square" lIns="0" tIns="0" rIns="0" bIns="0" rtlCol="0" anchor="t"/>
+          <a:lstStyle/>
+          <a:p>
+            <a:pPr algn="l" indent="0" marL="0">
+              <a:lnSpc>
+                <a:spcPts val="2990"/>
+              </a:lnSpc>
+              <a:buNone/>
+            </a:pPr>
+            <a:r>
+              <a:rPr lang="en-US" altLang="en-US" sz="2600" dirty="0">
+                <a:solidFill>
+                  <a:srgbClr val="111111"/>
+                </a:solidFill>
+                <a:latin typeface="Arial" pitchFamily="34" charset="0"/>
+                <a:ea typeface="Arial" pitchFamily="34" charset="-122"/>
+                <a:cs typeface="Arial" pitchFamily="34" charset="-120"/>
+              </a:rPr>
+              <a:t>Audit a teaching or assessment draft before use</a:t>
+            </a:r>
+            <a:endParaRPr lang="en-US" sz="2600" dirty="0"/>
+          </a:p>
+        </p:txBody>
+      </p:sp>
+      <p:sp>
+        <p:nvSpPr>
+          <p:cNvPr id="25" name="prompt_menu-shape-24"/>
+          <p:cNvSpPr/>
+          <p:nvPr/>
+        </p:nvSpPr>
+        <p:spPr>
+          <a:xfrm>
+            <a:off x="8585200" y="4622800"/>
+            <a:ext cx="6908800" cy="9144"/>
+          </a:xfrm>
+          <a:prstGeom prst="line">
+            <a:avLst/>
+          </a:prstGeom>
+          <a:ln w="12700">
+            <a:solidFill>
+              <a:srgbClr val="CCCCC5"/>
+            </a:solidFill>
+            <a:prstDash val="solid"/>
+          </a:ln>
+        </p:spPr>
+      </p:sp>
+      <p:sp>
+        <p:nvSpPr>
+          <p:cNvPr id="26" name="prompt_menu-text-25"/>
+          <p:cNvSpPr/>
+          <p:nvPr/>
+        </p:nvSpPr>
+        <p:spPr>
+          <a:xfrm>
+            <a:off x="8585200" y="4775200"/>
+            <a:ext cx="762000" cy="558800"/>
+          </a:xfrm>
+          <a:prstGeom prst="rect">
+            <a:avLst/>
+          </a:prstGeom>
+          <a:noFill/>
+          <a:ln/>
+        </p:spPr>
+        <p:txBody>
+          <a:bodyPr wrap="square" lIns="0" tIns="0" rIns="0" bIns="0" rtlCol="0" anchor="t"/>
+          <a:lstStyle/>
+          <a:p>
+            <a:pPr algn="l" indent="0" marL="0">
+              <a:buNone/>
+            </a:pPr>
+            <a:r>
+              <a:rPr lang="en-US" altLang="en-US" sz="3100" b="1" dirty="0">
+                <a:solidFill>
+                  <a:srgbClr val="E74627"/>
+                </a:solidFill>
+                <a:latin typeface="Arial" pitchFamily="34" charset="0"/>
+                <a:ea typeface="Arial" pitchFamily="34" charset="-122"/>
+                <a:cs typeface="Arial" pitchFamily="34" charset="-120"/>
+              </a:rPr>
+              <a:t>08</a:t>
+            </a:r>
+            <a:endParaRPr lang="en-US" sz="3100" dirty="0"/>
+          </a:p>
+        </p:txBody>
+      </p:sp>
+      <p:sp>
+        <p:nvSpPr>
+          <p:cNvPr id="27" name="prompt_menu-text-26"/>
+          <p:cNvSpPr/>
+          <p:nvPr/>
+        </p:nvSpPr>
+        <p:spPr>
+          <a:xfrm>
+            <a:off x="9359900" y="4749800"/>
+            <a:ext cx="6134100" cy="812800"/>
+          </a:xfrm>
+          <a:prstGeom prst="rect">
+            <a:avLst/>
+          </a:prstGeom>
+          <a:noFill/>
+          <a:ln/>
+        </p:spPr>
+        <p:txBody>
+          <a:bodyPr wrap="square" lIns="0" tIns="0" rIns="0" bIns="0" rtlCol="0" anchor="t"/>
+          <a:lstStyle/>
+          <a:p>
+            <a:pPr algn="l" indent="0" marL="0">
+              <a:lnSpc>
+                <a:spcPts val="2990"/>
+              </a:lnSpc>
+              <a:buNone/>
+            </a:pPr>
+            <a:r>
+              <a:rPr lang="en-US" altLang="en-US" sz="2600" dirty="0">
+                <a:solidFill>
+                  <a:srgbClr val="111111"/>
+                </a:solidFill>
+                <a:latin typeface="Arial" pitchFamily="34" charset="0"/>
+                <a:ea typeface="Arial" pitchFamily="34" charset="-122"/>
+                <a:cs typeface="Arial" pitchFamily="34" charset="-120"/>
+              </a:rPr>
+              <a:t>Turn a long EDB document into a staff briefing</a:t>
+            </a:r>
+            <a:endParaRPr lang="en-US" sz="2600" dirty="0"/>
+          </a:p>
+        </p:txBody>
+      </p:sp>
+      <p:sp>
+        <p:nvSpPr>
+          <p:cNvPr id="28" name="prompt_menu-shape-27"/>
+          <p:cNvSpPr/>
+          <p:nvPr/>
+        </p:nvSpPr>
+        <p:spPr>
+          <a:xfrm>
+            <a:off x="8585200" y="5638800"/>
+            <a:ext cx="6908800" cy="9144"/>
+          </a:xfrm>
+          <a:prstGeom prst="line">
+            <a:avLst/>
+          </a:prstGeom>
+          <a:ln w="12700">
+            <a:solidFill>
+              <a:srgbClr val="CCCCC5"/>
+            </a:solidFill>
+            <a:prstDash val="solid"/>
+          </a:ln>
+        </p:spPr>
+      </p:sp>
+      <p:sp>
+        <p:nvSpPr>
+          <p:cNvPr id="29" name="prompt_menu-text-28"/>
+          <p:cNvSpPr/>
+          <p:nvPr/>
+        </p:nvSpPr>
+        <p:spPr>
+          <a:xfrm>
+            <a:off x="8585200" y="5791200"/>
+            <a:ext cx="762000" cy="558800"/>
+          </a:xfrm>
+          <a:prstGeom prst="rect">
+            <a:avLst/>
+          </a:prstGeom>
+          <a:noFill/>
+          <a:ln/>
+        </p:spPr>
+        <p:txBody>
+          <a:bodyPr wrap="square" lIns="0" tIns="0" rIns="0" bIns="0" rtlCol="0" anchor="t"/>
+          <a:lstStyle/>
+          <a:p>
+            <a:pPr algn="l" indent="0" marL="0">
+              <a:buNone/>
+            </a:pPr>
+            <a:r>
+              <a:rPr lang="en-US" altLang="en-US" sz="3100" b="1" dirty="0">
+                <a:solidFill>
+                  <a:srgbClr val="E74627"/>
+                </a:solidFill>
+                <a:latin typeface="Arial" pitchFamily="34" charset="0"/>
+                <a:ea typeface="Arial" pitchFamily="34" charset="-122"/>
+                <a:cs typeface="Arial" pitchFamily="34" charset="-120"/>
+              </a:rPr>
+              <a:t>09</a:t>
+            </a:r>
+            <a:endParaRPr lang="en-US" sz="3100" dirty="0"/>
+          </a:p>
+        </p:txBody>
+      </p:sp>
+      <p:sp>
+        <p:nvSpPr>
+          <p:cNvPr id="30" name="prompt_menu-text-29"/>
+          <p:cNvSpPr/>
+          <p:nvPr/>
+        </p:nvSpPr>
+        <p:spPr>
+          <a:xfrm>
+            <a:off x="9359900" y="5765800"/>
+            <a:ext cx="6134100" cy="812800"/>
+          </a:xfrm>
+          <a:prstGeom prst="rect">
+            <a:avLst/>
+          </a:prstGeom>
+          <a:noFill/>
+          <a:ln/>
+        </p:spPr>
+        <p:txBody>
+          <a:bodyPr wrap="square" lIns="0" tIns="0" rIns="0" bIns="0" rtlCol="0" anchor="t"/>
+          <a:lstStyle/>
+          <a:p>
+            <a:pPr algn="l" indent="0" marL="0">
+              <a:lnSpc>
+                <a:spcPts val="2990"/>
+              </a:lnSpc>
+              <a:buNone/>
+            </a:pPr>
+            <a:r>
+              <a:rPr lang="en-US" altLang="en-US" sz="2600" dirty="0">
+                <a:solidFill>
+                  <a:srgbClr val="111111"/>
+                </a:solidFill>
+                <a:latin typeface="Arial" pitchFamily="34" charset="0"/>
+                <a:ea typeface="Arial" pitchFamily="34" charset="-122"/>
+                <a:cs typeface="Arial" pitchFamily="34" charset="-120"/>
+              </a:rPr>
+              <a:t>Extract actions, dates and unanswered questions</a:t>
+            </a:r>
+            <a:endParaRPr lang="en-US" sz="2600" dirty="0"/>
+          </a:p>
+        </p:txBody>
+      </p:sp>
+      <p:sp>
+        <p:nvSpPr>
+          <p:cNvPr id="31" name="prompt_menu-shape-30"/>
+          <p:cNvSpPr/>
+          <p:nvPr/>
+        </p:nvSpPr>
+        <p:spPr>
+          <a:xfrm>
+            <a:off x="8585200" y="6654800"/>
+            <a:ext cx="6908800" cy="9144"/>
+          </a:xfrm>
+          <a:prstGeom prst="line">
+            <a:avLst/>
+          </a:prstGeom>
+          <a:ln w="12700">
+            <a:solidFill>
+              <a:srgbClr val="CCCCC5"/>
+            </a:solidFill>
+            <a:prstDash val="solid"/>
+          </a:ln>
+        </p:spPr>
+      </p:sp>
+      <p:sp>
+        <p:nvSpPr>
+          <p:cNvPr id="32" name="prompt_menu-text-31"/>
+          <p:cNvSpPr/>
+          <p:nvPr/>
+        </p:nvSpPr>
+        <p:spPr>
+          <a:xfrm>
+            <a:off x="8585200" y="6807200"/>
+            <a:ext cx="762000" cy="558800"/>
+          </a:xfrm>
+          <a:prstGeom prst="rect">
+            <a:avLst/>
+          </a:prstGeom>
+          <a:noFill/>
+          <a:ln/>
+        </p:spPr>
+        <p:txBody>
+          <a:bodyPr wrap="square" lIns="0" tIns="0" rIns="0" bIns="0" rtlCol="0" anchor="t"/>
+          <a:lstStyle/>
+          <a:p>
+            <a:pPr algn="l" indent="0" marL="0">
+              <a:buNone/>
+            </a:pPr>
+            <a:r>
+              <a:rPr lang="en-US" altLang="en-US" sz="3100" b="1" dirty="0">
+                <a:solidFill>
+                  <a:srgbClr val="E74627"/>
+                </a:solidFill>
+                <a:latin typeface="Arial" pitchFamily="34" charset="0"/>
+                <a:ea typeface="Arial" pitchFamily="34" charset="-122"/>
+                <a:cs typeface="Arial" pitchFamily="34" charset="-120"/>
+              </a:rPr>
+              <a:t>10</a:t>
+            </a:r>
+            <a:endParaRPr lang="en-US" sz="3100" dirty="0"/>
+          </a:p>
+        </p:txBody>
+      </p:sp>
+      <p:sp>
+        <p:nvSpPr>
+          <p:cNvPr id="33" name="prompt_menu-text-32"/>
+          <p:cNvSpPr/>
+          <p:nvPr/>
+        </p:nvSpPr>
+        <p:spPr>
+          <a:xfrm>
+            <a:off x="9359900" y="6781800"/>
+            <a:ext cx="6134100" cy="812800"/>
+          </a:xfrm>
+          <a:prstGeom prst="rect">
+            <a:avLst/>
+          </a:prstGeom>
+          <a:noFill/>
+          <a:ln/>
+        </p:spPr>
+        <p:txBody>
+          <a:bodyPr wrap="square" lIns="0" tIns="0" rIns="0" bIns="0" rtlCol="0" anchor="t"/>
+          <a:lstStyle/>
+          <a:p>
+            <a:pPr algn="l" indent="0" marL="0">
+              <a:lnSpc>
+                <a:spcPts val="2990"/>
+              </a:lnSpc>
+              <a:buNone/>
+            </a:pPr>
+            <a:r>
+              <a:rPr lang="en-US" altLang="en-US" sz="2600" dirty="0">
+                <a:solidFill>
+                  <a:srgbClr val="111111"/>
+                </a:solidFill>
+                <a:latin typeface="Arial" pitchFamily="34" charset="0"/>
+                <a:ea typeface="Arial" pitchFamily="34" charset="-122"/>
+                <a:cs typeface="Arial" pitchFamily="34" charset="-120"/>
+              </a:rPr>
+              <a:t>Compare official documents: updates or contradictions?</a:t>
+            </a:r>
+            <a:endParaRPr lang="en-US" sz="2600" dirty="0"/>
+          </a:p>
+        </p:txBody>
+      </p:sp>
+      <p:sp>
+        <p:nvSpPr>
+          <p:cNvPr id="34" name="prompt_menu-shape-33"/>
+          <p:cNvSpPr/>
+          <p:nvPr/>
+        </p:nvSpPr>
+        <p:spPr>
+          <a:xfrm>
+            <a:off x="762000" y="8102600"/>
+            <a:ext cx="14732000" cy="9144"/>
+          </a:xfrm>
+          <a:prstGeom prst="line">
+            <a:avLst/>
+          </a:prstGeom>
+          <a:ln w="12700">
+            <a:solidFill>
+              <a:srgbClr val="CCCCC5"/>
+            </a:solidFill>
+            <a:prstDash val="solid"/>
+          </a:ln>
+        </p:spPr>
+      </p:sp>
+      <p:sp>
+        <p:nvSpPr>
+          <p:cNvPr id="35" name="prompt_menu-shape-34"/>
           <p:cNvSpPr/>
           <p:nvPr/>
         </p:nvSpPr>
@@ -8817,7 +8817,7 @@
       </p:sp>
       <p:pic>
         <p:nvPicPr>
-          <p:cNvPr id="8" name="example_chinese-image-7" descr="preencoded.png">    </p:cNvPr>
+          <p:cNvPr id="36" name="prompt_menu-image-35" descr="preencoded.png">    </p:cNvPr>
           <p:cNvPicPr>
             <a:picLocks noChangeAspect="1"/>
           </p:cNvPicPr>
@@ -8840,7 +8840,7 @@
       </p:pic>
       <p:sp>
         <p:nvSpPr>
-          <p:cNvPr id="9" name="example_chinese-text-8"/>
+          <p:cNvPr id="37" name="prompt_menu-text-36"/>
           <p:cNvSpPr/>
           <p:nvPr/>
         </p:nvSpPr>
@@ -8879,7 +8879,7 @@
       </p:sp>
       <p:sp>
         <p:nvSpPr>
-          <p:cNvPr id="10" name="example_chinese-text-9"/>
+          <p:cNvPr id="38" name="prompt_menu-text-37"/>
           <p:cNvSpPr/>
           <p:nvPr/>
         </p:nvSpPr>
@@ -8918,7 +8918,7 @@
       </p:sp>
       <p:sp>
         <p:nvSpPr>
-          <p:cNvPr id="11" name="example_chinese-text-10"/>
+          <p:cNvPr id="39" name="prompt_menu-text-38"/>
           <p:cNvSpPr/>
           <p:nvPr/>
         </p:nvSpPr>

</xml_diff>

<commit_message>
Update Studio output sharing wording
</commit_message>
<xml_diff>
--- a/downloads/Gemini-Notebook-Workshop.pptx
+++ b/downloads/Gemini-Notebook-Workshop.pptx
@@ -5810,7 +5810,7 @@
                 <a:ea typeface="Arial" pitchFamily="34" charset="-122"/>
                 <a:cs typeface="Arial" pitchFamily="34" charset="-120"/>
               </a:rPr>
-              <a:t>Post your comparison</a:t>
+              <a:t>Post your Studio</a:t>
             </a:r>
             <a:endParaRPr lang="en-US" sz="5400" dirty="0"/>
           </a:p>
@@ -5830,7 +5830,7 @@
                 <a:ea typeface="Arial" pitchFamily="34" charset="-122"/>
                 <a:cs typeface="Arial" pitchFamily="34" charset="-120"/>
               </a:rPr>
-              <a:t>on Padlet.</a:t>
+              <a:t>output.</a:t>
             </a:r>
             <a:endParaRPr lang="en-US" sz="5400" dirty="0"/>
           </a:p>
@@ -5901,7 +5901,7 @@
                 <a:ea typeface="Arial" pitchFamily="34" charset="-122"/>
                 <a:cs typeface="Arial" pitchFamily="34" charset="-120"/>
               </a:rPr>
-              <a:t>Upload the product or readable screenshots.</a:t>
+              <a:t>Upload the output or screenshot.</a:t>
             </a:r>
             <a:endParaRPr lang="en-US" sz="3800" dirty="0"/>
           </a:p>

</xml_diff>

<commit_message>
Match Padlet heading reference
</commit_message>
<xml_diff>
--- a/downloads/Gemini-Notebook-Workshop.pptx
+++ b/downloads/Gemini-Notebook-Workshop.pptx
@@ -5810,7 +5810,7 @@
                 <a:ea typeface="Arial" pitchFamily="34" charset="-122"/>
                 <a:cs typeface="Arial" pitchFamily="34" charset="-120"/>
               </a:rPr>
-              <a:t>Post your Studio</a:t>
+              <a:t>Post your Studio output</a:t>
             </a:r>
             <a:endParaRPr lang="en-US" sz="5400" dirty="0"/>
           </a:p>
@@ -5830,7 +5830,7 @@
                 <a:ea typeface="Arial" pitchFamily="34" charset="-122"/>
                 <a:cs typeface="Arial" pitchFamily="34" charset="-120"/>
               </a:rPr>
-              <a:t>output.</a:t>
+              <a:t>on Padlet.</a:t>
             </a:r>
             <a:endParaRPr lang="en-US" sz="5400" dirty="0"/>
           </a:p>

</xml_diff>